<commit_message>
Om CMU deck: SIMD/intrinsics/reuse/layout strip, assumptions slide, slide 7 split (alone vs layer; vs OpenCV), ONNX Runtime removed, inline asm explained
Co-Authored-By: Claude Opus 5.5 <noreply@anthropic.com>
Claude-Session: https://claude.ai/code/session_01AeVaHM9UcLNRWUmMTDhqz2
</commit_message>
<xml_diff>
--- a/docs/milestone/om/slides/om_mid_presentation_cmu.pptx
+++ b/docs/milestone/om/slides/om_mid_presentation_cmu.pptx
@@ -16,6 +16,8 @@
     <p:sldId id="261" r:id="rId23"/>
     <p:sldId id="262" r:id="rId24"/>
     <p:sldId id="263" r:id="rId25"/>
+    <p:sldId id="264" r:id="rId26"/>
+    <p:sldId id="265" r:id="rId27"/>
   </p:sldIdLst>
   <p:sldSz cy="5143500" cx="9144000"/>
   <p:notesSz cx="6858000" cy="9144000"/>
@@ -537,7 +539,219 @@
                 </a:solidFill>
                 <a:latin typeface="Open Sans"/>
               </a:rPr>
-              <a:t>32 layers, 1 thread, ms (lower is better)</a:t>
+              <a:t>Same 2×5 asm kernel, % of peak</a:t>
+            </a:r>
+          </a:p>
+        </c:rich>
+      </c:tx>
+      <c:layout/>
+      <c:overlay val="0"/>
+    </c:title>
+    <c:autoTitleDeleted val="0"/>
+    <c:plotArea>
+      <c:barChart>
+        <c:barDir val="col"/>
+        <c:grouping val="clustered"/>
+        <c:ser>
+          <c:idx val="0"/>
+          <c:order val="0"/>
+          <c:tx>
+            <c:strRef>
+              <c:f>Sheet1!$B$1</c:f>
+              <c:strCache>
+                <c:ptCount val="1"/>
+                <c:pt idx="0">
+                  <c:v>% of peak</c:v>
+                </c:pt>
+              </c:strCache>
+            </c:strRef>
+          </c:tx>
+          <c:spPr>
+            <a:solidFill>
+              <a:srgbClr val="0C6A87"/>
+            </a:solidFill>
+          </c:spPr>
+          <c:cat>
+            <c:strRef>
+              <c:f>Sheet1!$A$2:$A$4</c:f>
+              <c:strCache>
+                <c:ptCount val="3"/>
+                <c:pt idx="0">
+                  <c:v>alone (benchmark)</c:v>
+                </c:pt>
+                <c:pt idx="1">
+                  <c:v>in layers, inlined</c:v>
+                </c:pt>
+                <c:pt idx="2">
+                  <c:v>in layers, called as a function</c:v>
+                </c:pt>
+              </c:strCache>
+            </c:strRef>
+          </c:cat>
+          <c:val>
+            <c:numRef>
+              <c:f>Sheet1!$B$2:$B$4</c:f>
+              <c:numCache>
+                <c:formatCode>General</c:formatCode>
+                <c:ptCount val="3"/>
+                <c:pt idx="0">
+                  <c:v>92.2</c:v>
+                </c:pt>
+                <c:pt idx="1">
+                  <c:v>72.5</c:v>
+                </c:pt>
+                <c:pt idx="2">
+                  <c:v>83.1</c:v>
+                </c:pt>
+              </c:numCache>
+            </c:numRef>
+          </c:val>
+        </c:ser>
+        <c:dLbls>
+          <c:numFmt formatCode="0.0&quot;%&quot;" sourceLinked="0"/>
+          <c:txPr>
+            <a:bodyPr/>
+            <a:lstStyle/>
+            <a:p>
+              <a:pPr>
+                <a:defRPr sz="1100">
+                  <a:solidFill>
+                    <a:srgbClr val="1B2630"/>
+                  </a:solidFill>
+                  <a:latin typeface="Open Sans"/>
+                </a:defRPr>
+              </a:pPr>
+            </a:p>
+          </c:txPr>
+          <c:dLblPos val="outEnd"/>
+          <c:showLegendKey val="0"/>
+          <c:showVal val="1"/>
+          <c:showCatName val="0"/>
+          <c:showSerName val="0"/>
+          <c:showPercent val="0"/>
+          <c:showBubbleSize val="0"/>
+          <c:showLeaderLines val="1"/>
+        </c:dLbls>
+        <c:axId val="-2068027336"/>
+        <c:axId val="-2113994440"/>
+      </c:barChart>
+      <c:catAx>
+        <c:axId val="-2068027336"/>
+        <c:scaling>
+          <c:orientation val="minMax"/>
+        </c:scaling>
+        <c:delete val="0"/>
+        <c:axPos val="b"/>
+        <c:majorTickMark val="out"/>
+        <c:minorTickMark val="none"/>
+        <c:tickLblPos val="nextTo"/>
+        <c:spPr>
+          <a:ln>
+            <a:noFill/>
+          </a:ln>
+        </c:spPr>
+        <c:txPr>
+          <a:bodyPr/>
+          <a:lstStyle/>
+          <a:p>
+            <a:pPr>
+              <a:defRPr sz="1000">
+                <a:solidFill>
+                  <a:srgbClr val="5A6875"/>
+                </a:solidFill>
+                <a:latin typeface="Open Sans"/>
+              </a:defRPr>
+            </a:pPr>
+          </a:p>
+        </c:txPr>
+        <c:crossAx val="-2113994440"/>
+        <c:crosses val="autoZero"/>
+        <c:auto val="1"/>
+        <c:lblAlgn val="ctr"/>
+        <c:lblOffset val="100"/>
+        <c:noMultiLvlLbl val="0"/>
+      </c:catAx>
+      <c:valAx>
+        <c:axId val="-2113994440"/>
+        <c:scaling>
+          <c:max val="100.0"/>
+          <c:min val="0.0"/>
+        </c:scaling>
+        <c:delete val="0"/>
+        <c:axPos val="l"/>
+        <c:majorGridlines>
+          <c:spPr>
+            <a:ln>
+              <a:solidFill>
+                <a:srgbClr val="DDE3E7"/>
+              </a:solidFill>
+            </a:ln>
+          </c:spPr>
+        </c:majorGridlines>
+        <c:numFmt formatCode="0&quot;%&quot;" sourceLinked="0"/>
+        <c:majorTickMark val="out"/>
+        <c:minorTickMark val="none"/>
+        <c:tickLblPos val="nextTo"/>
+        <c:spPr>
+          <a:ln>
+            <a:noFill/>
+          </a:ln>
+        </c:spPr>
+        <c:txPr>
+          <a:bodyPr/>
+          <a:lstStyle/>
+          <a:p>
+            <a:pPr>
+              <a:defRPr sz="1000">
+                <a:solidFill>
+                  <a:srgbClr val="5A6875"/>
+                </a:solidFill>
+                <a:latin typeface="Open Sans"/>
+              </a:defRPr>
+            </a:pPr>
+          </a:p>
+        </c:txPr>
+        <c:crossAx val="-2068027336"/>
+        <c:crosses val="autoZero"/>
+        <c:majorUnit val="25.0"/>
+      </c:valAx>
+    </c:plotArea>
+    <c:dispBlanksAs val="gap"/>
+  </c:chart>
+  <c:txPr>
+    <a:bodyPr/>
+    <a:lstStyle/>
+    <a:p>
+      <a:pPr>
+        <a:defRPr sz="1800"/>
+      </a:pPr>
+      <a:endParaRPr lang="en-US"/>
+    </a:p>
+  </c:txPr>
+  <c:externalData r:id="rId1">
+    <c:autoUpdate val="0"/>
+  </c:externalData>
+</c:chartSpace>
+</file>
+
+<file path=ppt/charts/chart3.xml><?xml version="1.0" encoding="utf-8"?>
+<c:chartSpace xmlns:c="http://schemas.openxmlformats.org/drawingml/2006/chart" xmlns:a="http://schemas.openxmlformats.org/drawingml/2006/main" xmlns:r="http://schemas.openxmlformats.org/officeDocument/2006/relationships">
+  <c:date1904 val="0"/>
+  <c:chart>
+    <c:title>
+      <c:tx>
+        <c:rich>
+          <a:bodyPr/>
+          <a:lstStyle/>
+          <a:p>
+            <a:r>
+              <a:rPr sz="1200" b="0">
+                <a:solidFill>
+                  <a:srgbClr val="1B2630"/>
+                </a:solidFill>
+                <a:latin typeface="Open Sans"/>
+              </a:rPr>
+              <a:t>All 32 layers, 1 core, SiLU on: ms (lower is better)</a:t>
             </a:r>
           </a:p>
         </c:rich>
@@ -571,19 +785,16 @@
           </c:spPr>
           <c:cat>
             <c:strRef>
-              <c:f>Sheet1!$A$2:$A$5</c:f>
+              <c:f>Sheet1!$A$2:$A$4</c:f>
               <c:strCache>
-                <c:ptCount val="4"/>
+                <c:ptCount val="3"/>
                 <c:pt idx="0">
-                  <c:v>ONNX Runtime</c:v>
+                  <c:v>v10 (2×6 asm)</c:v>
                 </c:pt>
                 <c:pt idx="1">
-                  <c:v>v10 (2×6 asm)</c:v>
+                  <c:v>v2 (intrinsics)</c:v>
                 </c:pt>
                 <c:pt idx="2">
-                  <c:v>v2 (intrinsics)</c:v>
-                </c:pt>
-                <c:pt idx="3">
                   <c:v>OpenCV DNN</c:v>
                 </c:pt>
               </c:strCache>
@@ -591,20 +802,17 @@
           </c:cat>
           <c:val>
             <c:numRef>
-              <c:f>Sheet1!$B$2:$B$5</c:f>
+              <c:f>Sheet1!$B$2:$B$4</c:f>
               <c:numCache>
                 <c:formatCode>General</c:formatCode>
-                <c:ptCount val="4"/>
+                <c:ptCount val="3"/>
                 <c:pt idx="0">
-                  <c:v>62.6</c:v>
+                  <c:v>63.8</c:v>
                 </c:pt>
                 <c:pt idx="1">
-                  <c:v>63.8</c:v>
+                  <c:v>69.5</c:v>
                 </c:pt>
                 <c:pt idx="2">
-                  <c:v>69.5</c:v>
-                </c:pt>
-                <c:pt idx="3">
                   <c:v>86.4</c:v>
                 </c:pt>
               </c:numCache>
@@ -678,7 +886,7 @@
       <c:valAx>
         <c:axId val="-2113994440"/>
         <c:scaling>
-          <c:max val="110.0"/>
+          <c:max val="100.0"/>
           <c:min val="0.0"/>
         </c:scaling>
         <c:delete val="0"/>
@@ -1975,6 +2183,76 @@
 </p:notes>
 </file>
 
+<file path=ppt/notesSlides/notesSlide10.xml><?xml version="1.0" encoding="utf-8"?>
+<p:notes xmlns:a="http://schemas.openxmlformats.org/drawingml/2006/main" xmlns:p="http://schemas.openxmlformats.org/presentationml/2006/main" xmlns:r="http://schemas.openxmlformats.org/officeDocument/2006/relationships">
+  <p:cSld>
+    <p:spTree>
+      <p:nvGrpSpPr>
+        <p:cNvPr id="1" name=""/>
+        <p:cNvGrpSpPr/>
+        <p:nvPr/>
+      </p:nvGrpSpPr>
+      <p:grpSpPr>
+        <a:xfrm>
+          <a:off x="0" y="0"/>
+          <a:ext cx="0" cy="0"/>
+          <a:chOff x="0" y="0"/>
+          <a:chExt cx="0" cy="0"/>
+        </a:xfrm>
+      </p:grpSpPr>
+      <p:sp>
+        <p:nvSpPr>
+          <p:cNvPr id="2" name="Slide Image Placeholder 1"/>
+          <p:cNvSpPr>
+            <a:spLocks noGrp="1"/>
+          </p:cNvSpPr>
+          <p:nvPr>
+            <p:ph type="sldImg" idx="3"/>
+          </p:nvPr>
+        </p:nvSpPr>
+        <p:spPr/>
+      </p:sp>
+      <p:sp>
+        <p:nvSpPr>
+          <p:cNvPr id="3" name="Notes Placeholder 2"/>
+          <p:cNvSpPr>
+            <a:spLocks noGrp="1"/>
+          </p:cNvSpPr>
+          <p:nvPr>
+            <p:ph type="body" idx="1"/>
+          </p:nvPr>
+        </p:nvSpPr>
+        <p:spPr/>
+        <p:txBody>
+          <a:bodyPr/>
+          <a:lstStyle/>
+          <a:p>
+            <a:r>
+              <a:t>With the fused SiLU on, everything sits about 4 to 5 points lower: SiLU costs a fixed 160 to 290 cycles per call. Right: the 4x3 asm tile is the fastest while its weights are small, then collapses past C about 128 as its weights leave L2: the case cache blocking fixes.</a:t>
+            </a:r>
+          </a:p>
+        </p:txBody>
+      </p:sp>
+      <p:sp>
+        <p:nvSpPr>
+          <p:cNvPr id="4" name="Slide Number Placeholder 3"/>
+          <p:cNvSpPr>
+            <a:spLocks noGrp="1"/>
+          </p:cNvSpPr>
+          <p:nvPr>
+            <p:ph type="sldNum" idx="12"/>
+          </p:nvPr>
+        </p:nvSpPr>
+        <p:spPr/>
+      </p:sp>
+    </p:spTree>
+  </p:cSld>
+  <p:clrMapOvr>
+    <a:masterClrMapping/>
+  </p:clrMapOvr>
+</p:notes>
+</file>
+
 <file path=ppt/notesSlides/notesSlide2.xml><?xml version="1.0" encoding="utf-8"?>
 <p:notes xmlns:a="http://schemas.openxmlformats.org/drawingml/2006/main" xmlns:p="http://schemas.openxmlformats.org/presentationml/2006/main" xmlns:r="http://schemas.openxmlformats.org/officeDocument/2006/relationships">
   <p:cSld>
@@ -2160,7 +2438,7 @@
           <a:lstStyle/>
           <a:p>
             <a:r>
-              <a:t>Step 1: every output is an independent dot product; the only chain is the reduction. Step 2: 5-cycle latency times 2 FMAs per cycle means 10 independent accumulators, 80 outputs in flight. The chart: 1 accumulator is 10%, each adds about 10 points. Step 3: 2x5 gives 10 accumulators in 13 registers, 7 loads per 10 FMAs, and 5 divides 160, 80, 40 and 20. Step 4: benchmark the kernel alone exactly like Assignment 2.</a:t>
+              <a:t>These are the assumptions behind every number in the talk. The important one: cycles are wall time times 3.4 GHz, the CPU's maximum turbo, exactly the Assignment 2 convention. The core can never run faster than that, so the percentages can only understate.</a:t>
             </a:r>
           </a:p>
         </p:txBody>
@@ -2230,7 +2508,7 @@
           <a:lstStyle/>
           <a:p>
             <a:r>
-              <a:t>Every kernel I built, same arithmetic, same layout. Filled dots: the microkernel alone; hollow: all 32 layers. The 2x6 tile loses with intrinsics because GCC adds 11 register copies per tap at 15 live registers, but with the registers fixed in inline asm it is the best kernel, 95% alone. 4x3 needs all 16 registers; GCC spills it to 49%. Unrolling and software pipelining made it worse: full unrolling overflowed the uop cache and partial unrolling made GCC spill.</a:t>
+              <a:t>Step 1: every output is an independent dot product; the only chain is the reduction. Step 2: 5-cycle latency times 2 FMAs per cycle means 10 independent accumulators, 80 outputs in flight. The chart: 1 accumulator is 10%, each adds about 10 points. Step 3: 2x5 gives 10 accumulators in 13 registers, 7 loads per 10 FMAs, and 5 divides 160, 80, 40 and 20. Step 4: benchmark the kernel alone exactly like Assignment 2.</a:t>
             </a:r>
           </a:p>
         </p:txBody>
@@ -2300,7 +2578,7 @@
           <a:lstStyle/>
           <a:p>
             <a:r>
-              <a:t>This is the Assignment 2 figure for my kernel: FLOPs per cycle against the reduction length k. Cycles are time times 3.4 GHz, the max turbo, exactly as in Assignment 2, so this can only understate. 2x6 asm holds 30 to 31 FLOPs per cycle, 94 to 97 percent of peak; 2x5 intrinsics 83 to 89. The dip near k = 500 is the 2x5 weights leaving L1, like k = 315 in A2. Cross-checked: the hardware FP-instruction counter matches our FLOP count exactly.</a:t>
+              <a:t>Every kernel I built, same arithmetic, same layout. Filled dots: the microkernel alone; hollow: all 32 layers. The 2x6 tile loses with intrinsics because GCC adds 11 register copies per tap at 15 live registers, but with the registers fixed in inline asm it is the best kernel, 95% alone. 4x3 needs all 16 registers; GCC spills it to 49%. Unrolling and software pipelining made it worse: full unrolling overflowed the uop cache and partial unrolling made GCC spill.</a:t>
             </a:r>
           </a:p>
         </p:txBody>
@@ -2370,7 +2648,7 @@
           <a:lstStyle/>
           <a:p>
             <a:r>
-              <a:t>Kernel A, 2x5 in asm, beat kernel B, 2x5 intrinsics, by 7 points alone but lost by 4 in the layers. The assembly shows why: inlined into the layer loop, GCC keeps 3 accumulators on the stack and reloads them around every tap. Calling the microkernel as a function, exactly as the benchmark does, fixes it: 83.1% for 2x5 and 83.7% for v10, all at 3.4 GHz. v10 is 1.36 times faster than OpenCV and within 2% of ONNX Runtime on all 32 layers. Next: cache blocking and threading.</a:t>
+              <a:t>This is the Assignment 2 figure for my kernel: FLOPs per cycle against the reduction length k. Cycles are time times 3.4 GHz, the max turbo, exactly as in Assignment 2, so this can only understate. 2x6 asm holds 30 to 31 FLOPs per cycle, 94 to 97 percent of peak; 2x5 intrinsics 83 to 89. The dip near k = 500 is the 2x5 weights leaving L1, like k = 315 in A2. Cross-checked: the hardware FP-instruction counter matches our FLOP count exactly.</a:t>
             </a:r>
           </a:p>
         </p:txBody>
@@ -2440,7 +2718,77 @@
           <a:lstStyle/>
           <a:p>
             <a:r>
-              <a:t>With the fused SiLU on, everything sits about 4 to 5 points lower: SiLU costs a fixed 160 to 290 cycles per call. Right: the 4x3 asm tile is the fastest while its weights are small, then collapses past C about 128 as its weights leave L2: the case cache blocking fixes.</a:t>
+              <a:t>The 2x5 kernel written in assembly was the fastest alone, 92 percent, but inside the real layers it dropped to 72.5 percent, below the plain intrinsics version. The reason is in the code box: the compiler pastes the kernel into the layer loop, runs out of registers, and parks 3 of the 10 running sums in memory. It loads them back before every step and stores them after, which adds about 5 cycles to those chains: the latency problem again. The fix: call the kernel as a separate function, exactly as the benchmark does. Then all 10 sums stay in registers: 83 percent, and 84 percent with the 2x6 tile.</a:t>
+            </a:r>
+          </a:p>
+        </p:txBody>
+      </p:sp>
+      <p:sp>
+        <p:nvSpPr>
+          <p:cNvPr id="4" name="Slide Number Placeholder 3"/>
+          <p:cNvSpPr>
+            <a:spLocks noGrp="1"/>
+          </p:cNvSpPr>
+          <p:nvPr>
+            <p:ph type="sldNum" idx="12"/>
+          </p:nvPr>
+        </p:nvSpPr>
+        <p:spPr/>
+      </p:sp>
+    </p:spTree>
+  </p:cSld>
+  <p:clrMapOvr>
+    <a:masterClrMapping/>
+  </p:clrMapOvr>
+</p:notes>
+</file>
+
+<file path=ppt/notesSlides/notesSlide9.xml><?xml version="1.0" encoding="utf-8"?>
+<p:notes xmlns:a="http://schemas.openxmlformats.org/drawingml/2006/main" xmlns:p="http://schemas.openxmlformats.org/presentationml/2006/main" xmlns:r="http://schemas.openxmlformats.org/officeDocument/2006/relationships">
+  <p:cSld>
+    <p:spTree>
+      <p:nvGrpSpPr>
+        <p:cNvPr id="1" name=""/>
+        <p:cNvGrpSpPr/>
+        <p:nvPr/>
+      </p:nvGrpSpPr>
+      <p:grpSpPr>
+        <a:xfrm>
+          <a:off x="0" y="0"/>
+          <a:ext cx="0" cy="0"/>
+          <a:chOff x="0" y="0"/>
+          <a:chExt cx="0" cy="0"/>
+        </a:xfrm>
+      </p:grpSpPr>
+      <p:sp>
+        <p:nvSpPr>
+          <p:cNvPr id="2" name="Slide Image Placeholder 1"/>
+          <p:cNvSpPr>
+            <a:spLocks noGrp="1"/>
+          </p:cNvSpPr>
+          <p:nvPr>
+            <p:ph type="sldImg" idx="3"/>
+          </p:nvPr>
+        </p:nvSpPr>
+        <p:spPr/>
+      </p:sp>
+      <p:sp>
+        <p:nvSpPr>
+          <p:cNvPr id="3" name="Notes Placeholder 2"/>
+          <p:cNvSpPr>
+            <a:spLocks noGrp="1"/>
+          </p:cNvSpPr>
+          <p:nvPr>
+            <p:ph type="body" idx="1"/>
+          </p:nvPr>
+        </p:nvSpPr>
+        <p:spPr/>
+        <p:txBody>
+          <a:bodyPr/>
+          <a:lstStyle/>
+          <a:p>
+            <a:r>
+              <a:t>Total time for all 32 stride-1 layers, one core, same model and image. OpenCV DNN takes 86.4 milliseconds. Our first kernel, v2 with intrinsics, takes 69.5: 1.24 times faster. Our best, v10 with the 2x6 tile in assembly called as a function, takes 63.8: 1.36 times faster, at 84 percent of peak. Next: cache blocking for the layers with 128 or more input channels, and threading across 20 cores.</a:t>
             </a:r>
           </a:p>
         </p:txBody>
@@ -7085,6 +7433,163 @@
 </p:sld>
 </file>
 
+<file path=ppt/slides/slide10.xml><?xml version="1.0" encoding="utf-8"?>
+<p:sld xmlns:a="http://schemas.openxmlformats.org/drawingml/2006/main" xmlns:p="http://schemas.openxmlformats.org/presentationml/2006/main" xmlns:r="http://schemas.openxmlformats.org/officeDocument/2006/relationships">
+  <p:cSld>
+    <p:spTree>
+      <p:nvGrpSpPr>
+        <p:cNvPr id="1" name=""/>
+        <p:cNvGrpSpPr/>
+        <p:nvPr/>
+      </p:nvGrpSpPr>
+      <p:grpSpPr/>
+      <p:sp>
+        <p:nvSpPr>
+          <p:cNvPr id="2" name="Title 1"/>
+          <p:cNvSpPr>
+            <a:spLocks noGrp="1"/>
+          </p:cNvSpPr>
+          <p:nvPr>
+            <p:ph type="title"/>
+          </p:nvPr>
+        </p:nvSpPr>
+        <p:spPr/>
+        <p:txBody>
+          <a:bodyPr/>
+          <a:lstStyle/>
+          <a:p>
+            <a:r>
+              <a:t>Backup: the same sweeps with SiLU on</a:t>
+            </a:r>
+          </a:p>
+        </p:txBody>
+      </p:sp>
+      <p:pic>
+        <p:nvPicPr>
+          <p:cNvPr id="3" name="Picture 2" descr="ukr_sweep_2x6_34.png"/>
+          <p:cNvPicPr>
+            <a:picLocks noChangeAspect="1"/>
+          </p:cNvPicPr>
+          <p:nvPr/>
+        </p:nvPicPr>
+        <p:blipFill>
+          <a:blip r:embed="rId3"/>
+          <a:stretch>
+            <a:fillRect/>
+          </a:stretch>
+        </p:blipFill>
+        <p:spPr>
+          <a:xfrm>
+            <a:off x="457200" y="1051560"/>
+            <a:ext cx="4023360" cy="2145792"/>
+          </a:xfrm>
+          <a:prstGeom prst="rect">
+            <a:avLst/>
+          </a:prstGeom>
+        </p:spPr>
+      </p:pic>
+      <p:pic>
+        <p:nvPicPr>
+          <p:cNvPr id="4" name="Picture 3" descr="ukr_sweep_34.png"/>
+          <p:cNvPicPr>
+            <a:picLocks noChangeAspect="1"/>
+          </p:cNvPicPr>
+          <p:nvPr/>
+        </p:nvPicPr>
+        <p:blipFill>
+          <a:blip r:embed="rId4"/>
+          <a:stretch>
+            <a:fillRect/>
+          </a:stretch>
+        </p:blipFill>
+        <p:spPr>
+          <a:xfrm>
+            <a:off x="4663440" y="1051560"/>
+            <a:ext cx="4023360" cy="2145792"/>
+          </a:xfrm>
+          <a:prstGeom prst="rect">
+            <a:avLst/>
+          </a:prstGeom>
+        </p:spPr>
+      </p:pic>
+      <p:sp>
+        <p:nvSpPr>
+          <p:cNvPr id="5" name="TextBox 4"/>
+          <p:cNvSpPr txBox="1"/>
+          <p:nvPr/>
+        </p:nvSpPr>
+        <p:spPr>
+          <a:xfrm>
+            <a:off x="457200" y="3291840"/>
+            <a:ext cx="4023360" cy="640080"/>
+          </a:xfrm>
+          <a:prstGeom prst="rect">
+            <a:avLst/>
+          </a:prstGeom>
+          <a:noFill/>
+        </p:spPr>
+        <p:txBody>
+          <a:bodyPr wrap="square" lIns="0" rIns="0" tIns="0" bIns="0" anchor="t">
+            <a:spAutoFit/>
+          </a:bodyPr>
+          <a:lstStyle/>
+          <a:p>
+            <a:pPr algn="l"/>
+            <a:r>
+              <a:rPr sz="1050" b="0" i="0">
+                <a:solidFill>
+                  <a:srgbClr val="5A6875"/>
+                </a:solidFill>
+                <a:latin typeface="Open Sans"/>
+              </a:rPr>
+              <a:t>2×6 asm 90.2% mean (C = 32–256); 2×5 81.4%. SiLU costs a fixed 160–290 cycles per call.</a:t>
+            </a:r>
+          </a:p>
+        </p:txBody>
+      </p:sp>
+      <p:sp>
+        <p:nvSpPr>
+          <p:cNvPr id="6" name="TextBox 5"/>
+          <p:cNvSpPr txBox="1"/>
+          <p:nvPr/>
+        </p:nvSpPr>
+        <p:spPr>
+          <a:xfrm>
+            <a:off x="4663440" y="3291840"/>
+            <a:ext cx="4023360" cy="640080"/>
+          </a:xfrm>
+          <a:prstGeom prst="rect">
+            <a:avLst/>
+          </a:prstGeom>
+          <a:noFill/>
+        </p:spPr>
+        <p:txBody>
+          <a:bodyPr wrap="square" lIns="0" rIns="0" tIns="0" bIns="0" anchor="t">
+            <a:spAutoFit/>
+          </a:bodyPr>
+          <a:lstStyle/>
+          <a:p>
+            <a:pPr algn="l"/>
+            <a:r>
+              <a:rPr sz="1050" b="0" i="0">
+                <a:solidFill>
+                  <a:srgbClr val="5A6875"/>
+                </a:solidFill>
+                <a:latin typeface="Open Sans"/>
+              </a:rPr>
+              <a:t>4×3 asm: best 87.5% at C = 120, 57% at C = 256: its weights leave L2 (cache blocking fixes this).</a:t>
+            </a:r>
+          </a:p>
+        </p:txBody>
+      </p:sp>
+    </p:spTree>
+  </p:cSld>
+  <p:clrMapOvr>
+    <a:masterClrMapping/>
+  </p:clrMapOvr>
+</p:sld>
+</file>
+
 <file path=ppt/slides/slide2.xml><?xml version="1.0" encoding="utf-8"?>
 <p:sld xmlns:a="http://schemas.openxmlformats.org/drawingml/2006/main" xmlns:p="http://schemas.openxmlformats.org/presentationml/2006/main" xmlns:r="http://schemas.openxmlformats.org/officeDocument/2006/relationships">
   <p:cSld>
@@ -8163,8 +8668,8 @@
         </p:blipFill>
         <p:spPr>
           <a:xfrm>
-            <a:off x="457200" y="1051560"/>
-            <a:ext cx="8229600" cy="2396910"/>
+            <a:off x="1097280" y="960120"/>
+            <a:ext cx="6949440" cy="2024057"/>
           </a:xfrm>
           <a:prstGeom prst="rect">
             <a:avLst/>
@@ -8179,8 +8684,8 @@
         </p:nvSpPr>
         <p:spPr>
           <a:xfrm>
-            <a:off x="457200" y="3611880"/>
-            <a:ext cx="7132320" cy="548640"/>
+            <a:off x="457200" y="3017520"/>
+            <a:ext cx="8229600" cy="274320"/>
           </a:xfrm>
           <a:prstGeom prst="rect">
             <a:avLst/>
@@ -8195,13 +8700,477 @@
           <a:p>
             <a:pPr algn="l"/>
             <a:r>
-              <a:rPr sz="1300" b="0" i="0">
+              <a:rPr sz="1150" b="0" i="0">
                 <a:solidFill>
                   <a:srgbClr val="1B2630"/>
                 </a:solidFill>
                 <a:latin typeface="Open Sans"/>
               </a:rPr>
-              <a:t>Per step (one input channel at one of the 9 taps): load 2 weight vectors, broadcast 5 inputs, 10 FMAs. Repeat k = C × 9 times, then bias, SiLU and one store per register.</a:t>
+              <a:t>Per step: 2 weight loads + 5 broadcasts feed 10 FMAs; repeated k = C × 9 times, then bias, SiLU, one store.</a:t>
+            </a:r>
+          </a:p>
+        </p:txBody>
+      </p:sp>
+      <p:sp>
+        <p:nvSpPr>
+          <p:cNvPr id="5" name="strip-0"/>
+          <p:cNvSpPr/>
+          <p:nvPr/>
+        </p:nvSpPr>
+        <p:spPr>
+          <a:xfrm>
+            <a:off x="457200" y="3364992"/>
+            <a:ext cx="1965960" cy="841248"/>
+          </a:xfrm>
+          <a:prstGeom prst="roundRect">
+            <a:avLst>
+              <a:gd name="adj" fmla="val 8000"/>
+            </a:avLst>
+          </a:prstGeom>
+          <a:solidFill>
+            <a:srgbClr val="F8E5E9"/>
+          </a:solidFill>
+          <a:ln>
+            <a:noFill/>
+          </a:ln>
+          <a:effectLst/>
+        </p:spPr>
+        <p:style>
+          <a:lnRef idx="1">
+            <a:schemeClr val="accent1"/>
+          </a:lnRef>
+          <a:fillRef idx="3">
+            <a:schemeClr val="accent1"/>
+          </a:fillRef>
+          <a:effectRef idx="2">
+            <a:schemeClr val="accent1"/>
+          </a:effectRef>
+          <a:fontRef idx="minor">
+            <a:schemeClr val="lt1"/>
+          </a:fontRef>
+        </p:style>
+        <p:txBody>
+          <a:bodyPr rtlCol="0" anchor="ctr"/>
+          <a:lstStyle/>
+          <a:p>
+            <a:pPr algn="ctr"/>
+          </a:p>
+        </p:txBody>
+      </p:sp>
+      <p:sp>
+        <p:nvSpPr>
+          <p:cNvPr id="6" name="TextBox 5"/>
+          <p:cNvSpPr txBox="1"/>
+          <p:nvPr/>
+        </p:nvSpPr>
+        <p:spPr>
+          <a:xfrm>
+            <a:off x="548640" y="3419856"/>
+            <a:ext cx="1783080" cy="228600"/>
+          </a:xfrm>
+          <a:prstGeom prst="rect">
+            <a:avLst/>
+          </a:prstGeom>
+          <a:noFill/>
+        </p:spPr>
+        <p:txBody>
+          <a:bodyPr wrap="square" lIns="0" rIns="0" tIns="0" bIns="0" anchor="t">
+            <a:spAutoFit/>
+          </a:bodyPr>
+          <a:lstStyle/>
+          <a:p>
+            <a:pPr algn="l"/>
+            <a:r>
+              <a:rPr sz="1150" b="1" i="0">
+                <a:solidFill>
+                  <a:srgbClr val="BB0027"/>
+                </a:solidFill>
+                <a:latin typeface="Open Sans"/>
+              </a:rPr>
+              <a:t>SIMD</a:t>
+            </a:r>
+          </a:p>
+        </p:txBody>
+      </p:sp>
+      <p:sp>
+        <p:nvSpPr>
+          <p:cNvPr id="7" name="TextBox 6"/>
+          <p:cNvSpPr txBox="1"/>
+          <p:nvPr/>
+        </p:nvSpPr>
+        <p:spPr>
+          <a:xfrm>
+            <a:off x="548640" y="3648456"/>
+            <a:ext cx="1783080" cy="548640"/>
+          </a:xfrm>
+          <a:prstGeom prst="rect">
+            <a:avLst/>
+          </a:prstGeom>
+          <a:noFill/>
+        </p:spPr>
+        <p:txBody>
+          <a:bodyPr wrap="square" lIns="0" rIns="0" tIns="0" bIns="0" anchor="t">
+            <a:spAutoFit/>
+          </a:bodyPr>
+          <a:lstStyle/>
+          <a:p>
+            <a:pPr algn="l"/>
+            <a:r>
+              <a:rPr sz="950" b="0" i="0">
+                <a:solidFill>
+                  <a:srgbClr val="5A6875"/>
+                </a:solidFill>
+                <a:latin typeface="Open Sans"/>
+              </a:rPr>
+              <a:t>one vfmadd231ps = 8 multiply-adds (8 output channels): 32 FLOPs/cycle vs 4 scalar</a:t>
+            </a:r>
+          </a:p>
+        </p:txBody>
+      </p:sp>
+      <p:sp>
+        <p:nvSpPr>
+          <p:cNvPr id="8" name="strip-1"/>
+          <p:cNvSpPr/>
+          <p:nvPr/>
+        </p:nvSpPr>
+        <p:spPr>
+          <a:xfrm>
+            <a:off x="2542032" y="3364992"/>
+            <a:ext cx="1965960" cy="841248"/>
+          </a:xfrm>
+          <a:prstGeom prst="roundRect">
+            <a:avLst>
+              <a:gd name="adj" fmla="val 8000"/>
+            </a:avLst>
+          </a:prstGeom>
+          <a:solidFill>
+            <a:srgbClr val="F1F3F5"/>
+          </a:solidFill>
+          <a:ln>
+            <a:noFill/>
+          </a:ln>
+          <a:effectLst/>
+        </p:spPr>
+        <p:style>
+          <a:lnRef idx="1">
+            <a:schemeClr val="accent1"/>
+          </a:lnRef>
+          <a:fillRef idx="3">
+            <a:schemeClr val="accent1"/>
+          </a:fillRef>
+          <a:effectRef idx="2">
+            <a:schemeClr val="accent1"/>
+          </a:effectRef>
+          <a:fontRef idx="minor">
+            <a:schemeClr val="lt1"/>
+          </a:fontRef>
+        </p:style>
+        <p:txBody>
+          <a:bodyPr rtlCol="0" anchor="ctr"/>
+          <a:lstStyle/>
+          <a:p>
+            <a:pPr algn="ctr"/>
+          </a:p>
+        </p:txBody>
+      </p:sp>
+      <p:sp>
+        <p:nvSpPr>
+          <p:cNvPr id="9" name="TextBox 8"/>
+          <p:cNvSpPr txBox="1"/>
+          <p:nvPr/>
+        </p:nvSpPr>
+        <p:spPr>
+          <a:xfrm>
+            <a:off x="2633472" y="3419856"/>
+            <a:ext cx="1783080" cy="228600"/>
+          </a:xfrm>
+          <a:prstGeom prst="rect">
+            <a:avLst/>
+          </a:prstGeom>
+          <a:noFill/>
+        </p:spPr>
+        <p:txBody>
+          <a:bodyPr wrap="square" lIns="0" rIns="0" tIns="0" bIns="0" anchor="t">
+            <a:spAutoFit/>
+          </a:bodyPr>
+          <a:lstStyle/>
+          <a:p>
+            <a:pPr algn="l"/>
+            <a:r>
+              <a:rPr sz="1150" b="1" i="0">
+                <a:solidFill>
+                  <a:srgbClr val="1B2630"/>
+                </a:solidFill>
+                <a:latin typeface="Open Sans"/>
+              </a:rPr>
+              <a:t>Intrinsics</a:t>
+            </a:r>
+          </a:p>
+        </p:txBody>
+      </p:sp>
+      <p:sp>
+        <p:nvSpPr>
+          <p:cNvPr id="10" name="TextBox 9"/>
+          <p:cNvSpPr txBox="1"/>
+          <p:nvPr/>
+        </p:nvSpPr>
+        <p:spPr>
+          <a:xfrm>
+            <a:off x="2633472" y="3648456"/>
+            <a:ext cx="1783080" cy="548640"/>
+          </a:xfrm>
+          <a:prstGeom prst="rect">
+            <a:avLst/>
+          </a:prstGeom>
+          <a:noFill/>
+        </p:spPr>
+        <p:txBody>
+          <a:bodyPr wrap="square" lIns="0" rIns="0" tIns="0" bIns="0" anchor="t">
+            <a:spAutoFit/>
+          </a:bodyPr>
+          <a:lstStyle/>
+          <a:p>
+            <a:pPr algn="l"/>
+            <a:r>
+              <a:rPr sz="950" b="0" i="0">
+                <a:solidFill>
+                  <a:srgbClr val="5A6875"/>
+                </a:solidFill>
+                <a:latin typeface="Open Sans"/>
+              </a:rPr>
+              <a:t>C calls that are one instruction each, e.g. _mm256_fmadd_ps = vfmadd231ps</a:t>
+            </a:r>
+          </a:p>
+        </p:txBody>
+      </p:sp>
+      <p:sp>
+        <p:nvSpPr>
+          <p:cNvPr id="11" name="strip-2"/>
+          <p:cNvSpPr/>
+          <p:nvPr/>
+        </p:nvSpPr>
+        <p:spPr>
+          <a:xfrm>
+            <a:off x="4626864" y="3364992"/>
+            <a:ext cx="1965960" cy="841248"/>
+          </a:xfrm>
+          <a:prstGeom prst="roundRect">
+            <a:avLst>
+              <a:gd name="adj" fmla="val 8000"/>
+            </a:avLst>
+          </a:prstGeom>
+          <a:solidFill>
+            <a:srgbClr val="F1F3F5"/>
+          </a:solidFill>
+          <a:ln>
+            <a:noFill/>
+          </a:ln>
+          <a:effectLst/>
+        </p:spPr>
+        <p:style>
+          <a:lnRef idx="1">
+            <a:schemeClr val="accent1"/>
+          </a:lnRef>
+          <a:fillRef idx="3">
+            <a:schemeClr val="accent1"/>
+          </a:fillRef>
+          <a:effectRef idx="2">
+            <a:schemeClr val="accent1"/>
+          </a:effectRef>
+          <a:fontRef idx="minor">
+            <a:schemeClr val="lt1"/>
+          </a:fontRef>
+        </p:style>
+        <p:txBody>
+          <a:bodyPr rtlCol="0" anchor="ctr"/>
+          <a:lstStyle/>
+          <a:p>
+            <a:pPr algn="ctr"/>
+          </a:p>
+        </p:txBody>
+      </p:sp>
+      <p:sp>
+        <p:nvSpPr>
+          <p:cNvPr id="12" name="TextBox 11"/>
+          <p:cNvSpPr txBox="1"/>
+          <p:nvPr/>
+        </p:nvSpPr>
+        <p:spPr>
+          <a:xfrm>
+            <a:off x="4718303" y="3419856"/>
+            <a:ext cx="1783080" cy="228600"/>
+          </a:xfrm>
+          <a:prstGeom prst="rect">
+            <a:avLst/>
+          </a:prstGeom>
+          <a:noFill/>
+        </p:spPr>
+        <p:txBody>
+          <a:bodyPr wrap="square" lIns="0" rIns="0" tIns="0" bIns="0" anchor="t">
+            <a:spAutoFit/>
+          </a:bodyPr>
+          <a:lstStyle/>
+          <a:p>
+            <a:pPr algn="l"/>
+            <a:r>
+              <a:rPr sz="1150" b="1" i="0">
+                <a:solidFill>
+                  <a:srgbClr val="1B2630"/>
+                </a:solidFill>
+                <a:latin typeface="Open Sans"/>
+              </a:rPr>
+              <a:t>Reuse</a:t>
+            </a:r>
+          </a:p>
+        </p:txBody>
+      </p:sp>
+      <p:sp>
+        <p:nvSpPr>
+          <p:cNvPr id="13" name="TextBox 12"/>
+          <p:cNvSpPr txBox="1"/>
+          <p:nvPr/>
+        </p:nvSpPr>
+        <p:spPr>
+          <a:xfrm>
+            <a:off x="4718303" y="3648456"/>
+            <a:ext cx="1783080" cy="548640"/>
+          </a:xfrm>
+          <a:prstGeom prst="rect">
+            <a:avLst/>
+          </a:prstGeom>
+          <a:noFill/>
+        </p:spPr>
+        <p:txBody>
+          <a:bodyPr wrap="square" lIns="0" rIns="0" tIns="0" bIns="0" anchor="t">
+            <a:spAutoFit/>
+          </a:bodyPr>
+          <a:lstStyle/>
+          <a:p>
+            <a:pPr algn="l"/>
+            <a:r>
+              <a:rPr sz="950" b="0" i="0">
+                <a:solidFill>
+                  <a:srgbClr val="5A6875"/>
+                </a:solidFill>
+                <a:latin typeface="Open Sans"/>
+              </a:rPr>
+              <a:t>each weight vector used 5×, each broadcast 2×, each accumulator stored once</a:t>
+            </a:r>
+          </a:p>
+        </p:txBody>
+      </p:sp>
+      <p:sp>
+        <p:nvSpPr>
+          <p:cNvPr id="14" name="strip-3"/>
+          <p:cNvSpPr/>
+          <p:nvPr/>
+        </p:nvSpPr>
+        <p:spPr>
+          <a:xfrm>
+            <a:off x="6711696" y="3364992"/>
+            <a:ext cx="1965960" cy="841248"/>
+          </a:xfrm>
+          <a:prstGeom prst="roundRect">
+            <a:avLst>
+              <a:gd name="adj" fmla="val 8000"/>
+            </a:avLst>
+          </a:prstGeom>
+          <a:solidFill>
+            <a:srgbClr val="F1F3F5"/>
+          </a:solidFill>
+          <a:ln>
+            <a:noFill/>
+          </a:ln>
+          <a:effectLst/>
+        </p:spPr>
+        <p:style>
+          <a:lnRef idx="1">
+            <a:schemeClr val="accent1"/>
+          </a:lnRef>
+          <a:fillRef idx="3">
+            <a:schemeClr val="accent1"/>
+          </a:fillRef>
+          <a:effectRef idx="2">
+            <a:schemeClr val="accent1"/>
+          </a:effectRef>
+          <a:fontRef idx="minor">
+            <a:schemeClr val="lt1"/>
+          </a:fontRef>
+        </p:style>
+        <p:txBody>
+          <a:bodyPr rtlCol="0" anchor="ctr"/>
+          <a:lstStyle/>
+          <a:p>
+            <a:pPr algn="ctr"/>
+          </a:p>
+        </p:txBody>
+      </p:sp>
+      <p:sp>
+        <p:nvSpPr>
+          <p:cNvPr id="15" name="TextBox 14"/>
+          <p:cNvSpPr txBox="1"/>
+          <p:nvPr/>
+        </p:nvSpPr>
+        <p:spPr>
+          <a:xfrm>
+            <a:off x="6803136" y="3419856"/>
+            <a:ext cx="1783080" cy="228600"/>
+          </a:xfrm>
+          <a:prstGeom prst="rect">
+            <a:avLst/>
+          </a:prstGeom>
+          <a:noFill/>
+        </p:spPr>
+        <p:txBody>
+          <a:bodyPr wrap="square" lIns="0" rIns="0" tIns="0" bIns="0" anchor="t">
+            <a:spAutoFit/>
+          </a:bodyPr>
+          <a:lstStyle/>
+          <a:p>
+            <a:pPr algn="l"/>
+            <a:r>
+              <a:rPr sz="1150" b="1" i="0">
+                <a:solidFill>
+                  <a:srgbClr val="1B2630"/>
+                </a:solidFill>
+                <a:latin typeface="Open Sans"/>
+              </a:rPr>
+              <a:t>Layout</a:t>
+            </a:r>
+          </a:p>
+        </p:txBody>
+      </p:sp>
+      <p:sp>
+        <p:nvSpPr>
+          <p:cNvPr id="16" name="TextBox 15"/>
+          <p:cNvSpPr txBox="1"/>
+          <p:nvPr/>
+        </p:nvSpPr>
+        <p:spPr>
+          <a:xfrm>
+            <a:off x="6803136" y="3648456"/>
+            <a:ext cx="1783080" cy="548640"/>
+          </a:xfrm>
+          <a:prstGeom prst="rect">
+            <a:avLst/>
+          </a:prstGeom>
+          <a:noFill/>
+        </p:spPr>
+        <p:txBody>
+          <a:bodyPr wrap="square" lIns="0" rIns="0" tIns="0" bIns="0" anchor="t">
+            <a:spAutoFit/>
+          </a:bodyPr>
+          <a:lstStyle/>
+          <a:p>
+            <a:pPr algn="l"/>
+            <a:r>
+              <a:rPr sz="950" b="0" i="0">
+                <a:solidFill>
+                  <a:srgbClr val="5A6875"/>
+                </a:solidFill>
+                <a:latin typeface="Open Sans"/>
+              </a:rPr>
+              <a:t>8 channels of a pixel are contiguous: one aligned load fills one register</a:t>
             </a:r>
           </a:p>
         </p:txBody>
@@ -8215,6 +9184,973 @@
 </file>
 
 <file path=ppt/slides/slide4.xml><?xml version="1.0" encoding="utf-8"?>
+<p:sld xmlns:a="http://schemas.openxmlformats.org/drawingml/2006/main" xmlns:p="http://schemas.openxmlformats.org/presentationml/2006/main" xmlns:r="http://schemas.openxmlformats.org/officeDocument/2006/relationships">
+  <p:cSld>
+    <p:spTree>
+      <p:nvGrpSpPr>
+        <p:cNvPr id="1" name=""/>
+        <p:cNvGrpSpPr/>
+        <p:nvPr/>
+      </p:nvGrpSpPr>
+      <p:grpSpPr/>
+      <p:sp>
+        <p:nvSpPr>
+          <p:cNvPr id="2" name="Title 1"/>
+          <p:cNvSpPr>
+            <a:spLocks noGrp="1"/>
+          </p:cNvSpPr>
+          <p:nvPr>
+            <p:ph type="title"/>
+          </p:nvPr>
+        </p:nvSpPr>
+        <p:spPr/>
+        <p:txBody>
+          <a:bodyPr/>
+          <a:lstStyle/>
+          <a:p>
+            <a:r>
+              <a:t>How the numbers are measured</a:t>
+            </a:r>
+          </a:p>
+        </p:txBody>
+      </p:sp>
+      <p:sp>
+        <p:nvSpPr>
+          <p:cNvPr id="3" name="assume-0"/>
+          <p:cNvSpPr/>
+          <p:nvPr/>
+        </p:nvSpPr>
+        <p:spPr>
+          <a:xfrm>
+            <a:off x="457200" y="1005840"/>
+            <a:ext cx="4023360" cy="713232"/>
+          </a:xfrm>
+          <a:prstGeom prst="roundRect">
+            <a:avLst>
+              <a:gd name="adj" fmla="val 8000"/>
+            </a:avLst>
+          </a:prstGeom>
+          <a:solidFill>
+            <a:srgbClr val="F1F3F5"/>
+          </a:solidFill>
+          <a:ln>
+            <a:noFill/>
+          </a:ln>
+          <a:effectLst/>
+        </p:spPr>
+        <p:style>
+          <a:lnRef idx="1">
+            <a:schemeClr val="accent1"/>
+          </a:lnRef>
+          <a:fillRef idx="3">
+            <a:schemeClr val="accent1"/>
+          </a:fillRef>
+          <a:effectRef idx="2">
+            <a:schemeClr val="accent1"/>
+          </a:effectRef>
+          <a:fontRef idx="minor">
+            <a:schemeClr val="lt1"/>
+          </a:fontRef>
+        </p:style>
+        <p:txBody>
+          <a:bodyPr rtlCol="0" anchor="ctr"/>
+          <a:lstStyle/>
+          <a:p>
+            <a:pPr algn="ctr"/>
+          </a:p>
+        </p:txBody>
+      </p:sp>
+      <p:sp>
+        <p:nvSpPr>
+          <p:cNvPr id="4" name="TextBox 3"/>
+          <p:cNvSpPr txBox="1"/>
+          <p:nvPr/>
+        </p:nvSpPr>
+        <p:spPr>
+          <a:xfrm>
+            <a:off x="566928" y="1069848"/>
+            <a:ext cx="3749039" cy="228600"/>
+          </a:xfrm>
+          <a:prstGeom prst="rect">
+            <a:avLst/>
+          </a:prstGeom>
+          <a:noFill/>
+        </p:spPr>
+        <p:txBody>
+          <a:bodyPr wrap="square" lIns="0" rIns="0" tIns="0" bIns="0" anchor="t">
+            <a:spAutoFit/>
+          </a:bodyPr>
+          <a:lstStyle/>
+          <a:p>
+            <a:pPr algn="l"/>
+            <a:r>
+              <a:rPr sz="1150" b="1" i="0">
+                <a:solidFill>
+                  <a:srgbClr val="1B2630"/>
+                </a:solidFill>
+                <a:latin typeface="Open Sans"/>
+              </a:rPr>
+              <a:t>Machine</a:t>
+            </a:r>
+          </a:p>
+        </p:txBody>
+      </p:sp>
+      <p:sp>
+        <p:nvSpPr>
+          <p:cNvPr id="5" name="TextBox 4"/>
+          <p:cNvSpPr txBox="1"/>
+          <p:nvPr/>
+        </p:nvSpPr>
+        <p:spPr>
+          <a:xfrm>
+            <a:off x="566928" y="1307592"/>
+            <a:ext cx="3794760" cy="411480"/>
+          </a:xfrm>
+          <a:prstGeom prst="rect">
+            <a:avLst/>
+          </a:prstGeom>
+          <a:noFill/>
+        </p:spPr>
+        <p:txBody>
+          <a:bodyPr wrap="square" lIns="0" rIns="0" tIns="0" bIns="0" anchor="t">
+            <a:spAutoFit/>
+          </a:bodyPr>
+          <a:lstStyle/>
+          <a:p>
+            <a:pPr algn="l"/>
+            <a:r>
+              <a:rPr sz="950" b="0" i="0">
+                <a:solidFill>
+                  <a:srgbClr val="5A6875"/>
+                </a:solidFill>
+                <a:latin typeface="Open Sans"/>
+              </a:rPr>
+              <a:t>ece028, Xeon E5-2640 v4 (Broadwell), 1 core pinned with taskset, GCC 8.5 -O3 -march=broadwell</a:t>
+            </a:r>
+          </a:p>
+        </p:txBody>
+      </p:sp>
+      <p:sp>
+        <p:nvSpPr>
+          <p:cNvPr id="6" name="assume-1"/>
+          <p:cNvSpPr/>
+          <p:nvPr/>
+        </p:nvSpPr>
+        <p:spPr>
+          <a:xfrm>
+            <a:off x="4617720" y="1005840"/>
+            <a:ext cx="4023360" cy="713232"/>
+          </a:xfrm>
+          <a:prstGeom prst="roundRect">
+            <a:avLst>
+              <a:gd name="adj" fmla="val 8000"/>
+            </a:avLst>
+          </a:prstGeom>
+          <a:solidFill>
+            <a:srgbClr val="F1F3F5"/>
+          </a:solidFill>
+          <a:ln>
+            <a:noFill/>
+          </a:ln>
+          <a:effectLst/>
+        </p:spPr>
+        <p:style>
+          <a:lnRef idx="1">
+            <a:schemeClr val="accent1"/>
+          </a:lnRef>
+          <a:fillRef idx="3">
+            <a:schemeClr val="accent1"/>
+          </a:fillRef>
+          <a:effectRef idx="2">
+            <a:schemeClr val="accent1"/>
+          </a:effectRef>
+          <a:fontRef idx="minor">
+            <a:schemeClr val="lt1"/>
+          </a:fontRef>
+        </p:style>
+        <p:txBody>
+          <a:bodyPr rtlCol="0" anchor="ctr"/>
+          <a:lstStyle/>
+          <a:p>
+            <a:pPr algn="ctr"/>
+          </a:p>
+        </p:txBody>
+      </p:sp>
+      <p:sp>
+        <p:nvSpPr>
+          <p:cNvPr id="7" name="TextBox 6"/>
+          <p:cNvSpPr txBox="1"/>
+          <p:nvPr/>
+        </p:nvSpPr>
+        <p:spPr>
+          <a:xfrm>
+            <a:off x="4727448" y="1069848"/>
+            <a:ext cx="3749039" cy="228600"/>
+          </a:xfrm>
+          <a:prstGeom prst="rect">
+            <a:avLst/>
+          </a:prstGeom>
+          <a:noFill/>
+        </p:spPr>
+        <p:txBody>
+          <a:bodyPr wrap="square" lIns="0" rIns="0" tIns="0" bIns="0" anchor="t">
+            <a:spAutoFit/>
+          </a:bodyPr>
+          <a:lstStyle/>
+          <a:p>
+            <a:pPr algn="l"/>
+            <a:r>
+              <a:rPr sz="1150" b="1" i="0">
+                <a:solidFill>
+                  <a:srgbClr val="1B2630"/>
+                </a:solidFill>
+                <a:latin typeface="Open Sans"/>
+              </a:rPr>
+              <a:t>Peak</a:t>
+            </a:r>
+          </a:p>
+        </p:txBody>
+      </p:sp>
+      <p:sp>
+        <p:nvSpPr>
+          <p:cNvPr id="8" name="TextBox 7"/>
+          <p:cNvSpPr txBox="1"/>
+          <p:nvPr/>
+        </p:nvSpPr>
+        <p:spPr>
+          <a:xfrm>
+            <a:off x="4727448" y="1307592"/>
+            <a:ext cx="3794760" cy="411480"/>
+          </a:xfrm>
+          <a:prstGeom prst="rect">
+            <a:avLst/>
+          </a:prstGeom>
+          <a:noFill/>
+        </p:spPr>
+        <p:txBody>
+          <a:bodyPr wrap="square" lIns="0" rIns="0" tIns="0" bIns="0" anchor="t">
+            <a:spAutoFit/>
+          </a:bodyPr>
+          <a:lstStyle/>
+          <a:p>
+            <a:pPr algn="l"/>
+            <a:r>
+              <a:rPr sz="950" b="0" i="0">
+                <a:solidFill>
+                  <a:srgbClr val="5A6875"/>
+                </a:solidFill>
+                <a:latin typeface="Open Sans"/>
+              </a:rPr>
+              <a:t>2 FMA units × 8 FP32 lanes × 2 FLOPs = 32 FLOPs/cycle per core (AVX2, no AVX-512)</a:t>
+            </a:r>
+          </a:p>
+        </p:txBody>
+      </p:sp>
+      <p:sp>
+        <p:nvSpPr>
+          <p:cNvPr id="9" name="assume-2"/>
+          <p:cNvSpPr/>
+          <p:nvPr/>
+        </p:nvSpPr>
+        <p:spPr>
+          <a:xfrm>
+            <a:off x="457200" y="1810512"/>
+            <a:ext cx="4023360" cy="713232"/>
+          </a:xfrm>
+          <a:prstGeom prst="roundRect">
+            <a:avLst>
+              <a:gd name="adj" fmla="val 8000"/>
+            </a:avLst>
+          </a:prstGeom>
+          <a:solidFill>
+            <a:srgbClr val="F1F3F5"/>
+          </a:solidFill>
+          <a:ln>
+            <a:noFill/>
+          </a:ln>
+          <a:effectLst/>
+        </p:spPr>
+        <p:style>
+          <a:lnRef idx="1">
+            <a:schemeClr val="accent1"/>
+          </a:lnRef>
+          <a:fillRef idx="3">
+            <a:schemeClr val="accent1"/>
+          </a:fillRef>
+          <a:effectRef idx="2">
+            <a:schemeClr val="accent1"/>
+          </a:effectRef>
+          <a:fontRef idx="minor">
+            <a:schemeClr val="lt1"/>
+          </a:fontRef>
+        </p:style>
+        <p:txBody>
+          <a:bodyPr rtlCol="0" anchor="ctr"/>
+          <a:lstStyle/>
+          <a:p>
+            <a:pPr algn="ctr"/>
+          </a:p>
+        </p:txBody>
+      </p:sp>
+      <p:sp>
+        <p:nvSpPr>
+          <p:cNvPr id="10" name="TextBox 9"/>
+          <p:cNvSpPr txBox="1"/>
+          <p:nvPr/>
+        </p:nvSpPr>
+        <p:spPr>
+          <a:xfrm>
+            <a:off x="566928" y="1874519"/>
+            <a:ext cx="3749039" cy="228600"/>
+          </a:xfrm>
+          <a:prstGeom prst="rect">
+            <a:avLst/>
+          </a:prstGeom>
+          <a:noFill/>
+        </p:spPr>
+        <p:txBody>
+          <a:bodyPr wrap="square" lIns="0" rIns="0" tIns="0" bIns="0" anchor="t">
+            <a:spAutoFit/>
+          </a:bodyPr>
+          <a:lstStyle/>
+          <a:p>
+            <a:pPr algn="l"/>
+            <a:r>
+              <a:rPr sz="1150" b="1" i="0">
+                <a:solidFill>
+                  <a:srgbClr val="BB0027"/>
+                </a:solidFill>
+                <a:latin typeface="Open Sans"/>
+              </a:rPr>
+              <a:t>Cycles</a:t>
+            </a:r>
+          </a:p>
+        </p:txBody>
+      </p:sp>
+      <p:sp>
+        <p:nvSpPr>
+          <p:cNvPr id="11" name="TextBox 10"/>
+          <p:cNvSpPr txBox="1"/>
+          <p:nvPr/>
+        </p:nvSpPr>
+        <p:spPr>
+          <a:xfrm>
+            <a:off x="566928" y="2112264"/>
+            <a:ext cx="3794760" cy="411480"/>
+          </a:xfrm>
+          <a:prstGeom prst="rect">
+            <a:avLst/>
+          </a:prstGeom>
+          <a:noFill/>
+        </p:spPr>
+        <p:txBody>
+          <a:bodyPr wrap="square" lIns="0" rIns="0" tIns="0" bIns="0" anchor="t">
+            <a:spAutoFit/>
+          </a:bodyPr>
+          <a:lstStyle/>
+          <a:p>
+            <a:pPr algn="l"/>
+            <a:r>
+              <a:rPr sz="950" b="0" i="0">
+                <a:solidFill>
+                  <a:srgbClr val="5A6875"/>
+                </a:solidFill>
+                <a:latin typeface="Open Sans"/>
+              </a:rPr>
+              <a:t>wall time × 3.4 GHz (max turbo), as in Assignment 2: can only understate % of peak</a:t>
+            </a:r>
+          </a:p>
+        </p:txBody>
+      </p:sp>
+      <p:sp>
+        <p:nvSpPr>
+          <p:cNvPr id="12" name="assume-3"/>
+          <p:cNvSpPr/>
+          <p:nvPr/>
+        </p:nvSpPr>
+        <p:spPr>
+          <a:xfrm>
+            <a:off x="4617720" y="1810512"/>
+            <a:ext cx="4023360" cy="713232"/>
+          </a:xfrm>
+          <a:prstGeom prst="roundRect">
+            <a:avLst>
+              <a:gd name="adj" fmla="val 8000"/>
+            </a:avLst>
+          </a:prstGeom>
+          <a:solidFill>
+            <a:srgbClr val="F1F3F5"/>
+          </a:solidFill>
+          <a:ln>
+            <a:noFill/>
+          </a:ln>
+          <a:effectLst/>
+        </p:spPr>
+        <p:style>
+          <a:lnRef idx="1">
+            <a:schemeClr val="accent1"/>
+          </a:lnRef>
+          <a:fillRef idx="3">
+            <a:schemeClr val="accent1"/>
+          </a:fillRef>
+          <a:effectRef idx="2">
+            <a:schemeClr val="accent1"/>
+          </a:effectRef>
+          <a:fontRef idx="minor">
+            <a:schemeClr val="lt1"/>
+          </a:fontRef>
+        </p:style>
+        <p:txBody>
+          <a:bodyPr rtlCol="0" anchor="ctr"/>
+          <a:lstStyle/>
+          <a:p>
+            <a:pPr algn="ctr"/>
+          </a:p>
+        </p:txBody>
+      </p:sp>
+      <p:sp>
+        <p:nvSpPr>
+          <p:cNvPr id="13" name="TextBox 12"/>
+          <p:cNvSpPr txBox="1"/>
+          <p:nvPr/>
+        </p:nvSpPr>
+        <p:spPr>
+          <a:xfrm>
+            <a:off x="4727448" y="1874519"/>
+            <a:ext cx="3749039" cy="228600"/>
+          </a:xfrm>
+          <a:prstGeom prst="rect">
+            <a:avLst/>
+          </a:prstGeom>
+          <a:noFill/>
+        </p:spPr>
+        <p:txBody>
+          <a:bodyPr wrap="square" lIns="0" rIns="0" tIns="0" bIns="0" anchor="t">
+            <a:spAutoFit/>
+          </a:bodyPr>
+          <a:lstStyle/>
+          <a:p>
+            <a:pPr algn="l"/>
+            <a:r>
+              <a:rPr sz="1150" b="1" i="0">
+                <a:solidFill>
+                  <a:srgbClr val="1B2630"/>
+                </a:solidFill>
+                <a:latin typeface="Open Sans"/>
+              </a:rPr>
+              <a:t>FLOPs</a:t>
+            </a:r>
+          </a:p>
+        </p:txBody>
+      </p:sp>
+      <p:sp>
+        <p:nvSpPr>
+          <p:cNvPr id="14" name="TextBox 13"/>
+          <p:cNvSpPr txBox="1"/>
+          <p:nvPr/>
+        </p:nvSpPr>
+        <p:spPr>
+          <a:xfrm>
+            <a:off x="4727448" y="2112264"/>
+            <a:ext cx="3794760" cy="411480"/>
+          </a:xfrm>
+          <a:prstGeom prst="rect">
+            <a:avLst/>
+          </a:prstGeom>
+          <a:noFill/>
+        </p:spPr>
+        <p:txBody>
+          <a:bodyPr wrap="square" lIns="0" rIns="0" tIns="0" bIns="0" anchor="t">
+            <a:spAutoFit/>
+          </a:bodyPr>
+          <a:lstStyle/>
+          <a:p>
+            <a:pPr algn="l"/>
+            <a:r>
+              <a:rPr sz="950" b="0" i="0">
+                <a:solidFill>
+                  <a:srgbClr val="5A6875"/>
+                </a:solidFill>
+                <a:latin typeface="Open Sans"/>
+              </a:rPr>
+              <a:t>2 × outputs × C × 9: only the convolution's multiply-adds; bias and SiLU count as zero</a:t>
+            </a:r>
+          </a:p>
+        </p:txBody>
+      </p:sp>
+      <p:sp>
+        <p:nvSpPr>
+          <p:cNvPr id="15" name="assume-4"/>
+          <p:cNvSpPr/>
+          <p:nvPr/>
+        </p:nvSpPr>
+        <p:spPr>
+          <a:xfrm>
+            <a:off x="457200" y="2615184"/>
+            <a:ext cx="4023360" cy="713232"/>
+          </a:xfrm>
+          <a:prstGeom prst="roundRect">
+            <a:avLst>
+              <a:gd name="adj" fmla="val 8000"/>
+            </a:avLst>
+          </a:prstGeom>
+          <a:solidFill>
+            <a:srgbClr val="F1F3F5"/>
+          </a:solidFill>
+          <a:ln>
+            <a:noFill/>
+          </a:ln>
+          <a:effectLst/>
+        </p:spPr>
+        <p:style>
+          <a:lnRef idx="1">
+            <a:schemeClr val="accent1"/>
+          </a:lnRef>
+          <a:fillRef idx="3">
+            <a:schemeClr val="accent1"/>
+          </a:fillRef>
+          <a:effectRef idx="2">
+            <a:schemeClr val="accent1"/>
+          </a:effectRef>
+          <a:fontRef idx="minor">
+            <a:schemeClr val="lt1"/>
+          </a:fontRef>
+        </p:style>
+        <p:txBody>
+          <a:bodyPr rtlCol="0" anchor="ctr"/>
+          <a:lstStyle/>
+          <a:p>
+            <a:pPr algn="ctr"/>
+          </a:p>
+        </p:txBody>
+      </p:sp>
+      <p:sp>
+        <p:nvSpPr>
+          <p:cNvPr id="16" name="TextBox 15"/>
+          <p:cNvSpPr txBox="1"/>
+          <p:nvPr/>
+        </p:nvSpPr>
+        <p:spPr>
+          <a:xfrm>
+            <a:off x="566928" y="2679192"/>
+            <a:ext cx="3749039" cy="228600"/>
+          </a:xfrm>
+          <a:prstGeom prst="rect">
+            <a:avLst/>
+          </a:prstGeom>
+          <a:noFill/>
+        </p:spPr>
+        <p:txBody>
+          <a:bodyPr wrap="square" lIns="0" rIns="0" tIns="0" bIns="0" anchor="t">
+            <a:spAutoFit/>
+          </a:bodyPr>
+          <a:lstStyle/>
+          <a:p>
+            <a:pPr algn="l"/>
+            <a:r>
+              <a:rPr sz="1150" b="1" i="0">
+                <a:solidFill>
+                  <a:srgbClr val="1B2630"/>
+                </a:solidFill>
+                <a:latin typeface="Open Sans"/>
+              </a:rPr>
+              <a:t>Microkernel alone</a:t>
+            </a:r>
+          </a:p>
+        </p:txBody>
+      </p:sp>
+      <p:sp>
+        <p:nvSpPr>
+          <p:cNvPr id="17" name="TextBox 16"/>
+          <p:cNvSpPr txBox="1"/>
+          <p:nvPr/>
+        </p:nvSpPr>
+        <p:spPr>
+          <a:xfrm>
+            <a:off x="566928" y="2916936"/>
+            <a:ext cx="3794760" cy="411480"/>
+          </a:xfrm>
+          <a:prstGeom prst="rect">
+            <a:avLst/>
+          </a:prstGeom>
+          <a:noFill/>
+        </p:spPr>
+        <p:txBody>
+          <a:bodyPr wrap="square" lIns="0" rIns="0" tIns="0" bIns="0" anchor="t">
+            <a:spAutoFit/>
+          </a:bodyPr>
+          <a:lstStyle/>
+          <a:p>
+            <a:pPr algn="l"/>
+            <a:r>
+              <a:rPr sz="950" b="0" i="0">
+                <a:solidFill>
+                  <a:srgbClr val="5A6875"/>
+                </a:solidFill>
+                <a:latin typeface="Open Sans"/>
+              </a:rPr>
+              <a:t>one tile of data reused (stays in L1/L2), 2 s warm-up, best of 3 runs, SiLU off</a:t>
+            </a:r>
+          </a:p>
+        </p:txBody>
+      </p:sp>
+      <p:sp>
+        <p:nvSpPr>
+          <p:cNvPr id="18" name="assume-5"/>
+          <p:cNvSpPr/>
+          <p:nvPr/>
+        </p:nvSpPr>
+        <p:spPr>
+          <a:xfrm>
+            <a:off x="4617720" y="2615184"/>
+            <a:ext cx="4023360" cy="713232"/>
+          </a:xfrm>
+          <a:prstGeom prst="roundRect">
+            <a:avLst>
+              <a:gd name="adj" fmla="val 8000"/>
+            </a:avLst>
+          </a:prstGeom>
+          <a:solidFill>
+            <a:srgbClr val="F1F3F5"/>
+          </a:solidFill>
+          <a:ln>
+            <a:noFill/>
+          </a:ln>
+          <a:effectLst/>
+        </p:spPr>
+        <p:style>
+          <a:lnRef idx="1">
+            <a:schemeClr val="accent1"/>
+          </a:lnRef>
+          <a:fillRef idx="3">
+            <a:schemeClr val="accent1"/>
+          </a:fillRef>
+          <a:effectRef idx="2">
+            <a:schemeClr val="accent1"/>
+          </a:effectRef>
+          <a:fontRef idx="minor">
+            <a:schemeClr val="lt1"/>
+          </a:fontRef>
+        </p:style>
+        <p:txBody>
+          <a:bodyPr rtlCol="0" anchor="ctr"/>
+          <a:lstStyle/>
+          <a:p>
+            <a:pPr algn="ctr"/>
+          </a:p>
+        </p:txBody>
+      </p:sp>
+      <p:sp>
+        <p:nvSpPr>
+          <p:cNvPr id="19" name="TextBox 18"/>
+          <p:cNvSpPr txBox="1"/>
+          <p:nvPr/>
+        </p:nvSpPr>
+        <p:spPr>
+          <a:xfrm>
+            <a:off x="4727448" y="2679192"/>
+            <a:ext cx="3749039" cy="228600"/>
+          </a:xfrm>
+          <a:prstGeom prst="rect">
+            <a:avLst/>
+          </a:prstGeom>
+          <a:noFill/>
+        </p:spPr>
+        <p:txBody>
+          <a:bodyPr wrap="square" lIns="0" rIns="0" tIns="0" bIns="0" anchor="t">
+            <a:spAutoFit/>
+          </a:bodyPr>
+          <a:lstStyle/>
+          <a:p>
+            <a:pPr algn="l"/>
+            <a:r>
+              <a:rPr sz="1150" b="1" i="0">
+                <a:solidFill>
+                  <a:srgbClr val="1B2630"/>
+                </a:solidFill>
+                <a:latin typeface="Open Sans"/>
+              </a:rPr>
+              <a:t>Full layers</a:t>
+            </a:r>
+          </a:p>
+        </p:txBody>
+      </p:sp>
+      <p:sp>
+        <p:nvSpPr>
+          <p:cNvPr id="20" name="TextBox 19"/>
+          <p:cNvSpPr txBox="1"/>
+          <p:nvPr/>
+        </p:nvSpPr>
+        <p:spPr>
+          <a:xfrm>
+            <a:off x="4727448" y="2916936"/>
+            <a:ext cx="3794760" cy="411480"/>
+          </a:xfrm>
+          <a:prstGeom prst="rect">
+            <a:avLst/>
+          </a:prstGeom>
+          <a:noFill/>
+        </p:spPr>
+        <p:txBody>
+          <a:bodyPr wrap="square" lIns="0" rIns="0" tIns="0" bIns="0" anchor="t">
+            <a:spAutoFit/>
+          </a:bodyPr>
+          <a:lstStyle/>
+          <a:p>
+            <a:pPr algn="l"/>
+            <a:r>
+              <a:rPr sz="950" b="0" i="0">
+                <a:solidFill>
+                  <a:srgbClr val="5A6875"/>
+                </a:solidFill>
+                <a:latin typeface="Open Sans"/>
+              </a:rPr>
+              <a:t>all 32 real YOLOv8n layers, batch 1, 640 × 640 image, FP32, SiLU on</a:t>
+            </a:r>
+          </a:p>
+        </p:txBody>
+      </p:sp>
+      <p:sp>
+        <p:nvSpPr>
+          <p:cNvPr id="21" name="assume-6"/>
+          <p:cNvSpPr/>
+          <p:nvPr/>
+        </p:nvSpPr>
+        <p:spPr>
+          <a:xfrm>
+            <a:off x="457200" y="3419856"/>
+            <a:ext cx="4023360" cy="713232"/>
+          </a:xfrm>
+          <a:prstGeom prst="roundRect">
+            <a:avLst>
+              <a:gd name="adj" fmla="val 8000"/>
+            </a:avLst>
+          </a:prstGeom>
+          <a:solidFill>
+            <a:srgbClr val="F1F3F5"/>
+          </a:solidFill>
+          <a:ln>
+            <a:noFill/>
+          </a:ln>
+          <a:effectLst/>
+        </p:spPr>
+        <p:style>
+          <a:lnRef idx="1">
+            <a:schemeClr val="accent1"/>
+          </a:lnRef>
+          <a:fillRef idx="3">
+            <a:schemeClr val="accent1"/>
+          </a:fillRef>
+          <a:effectRef idx="2">
+            <a:schemeClr val="accent1"/>
+          </a:effectRef>
+          <a:fontRef idx="minor">
+            <a:schemeClr val="lt1"/>
+          </a:fontRef>
+        </p:style>
+        <p:txBody>
+          <a:bodyPr rtlCol="0" anchor="ctr"/>
+          <a:lstStyle/>
+          <a:p>
+            <a:pPr algn="ctr"/>
+          </a:p>
+        </p:txBody>
+      </p:sp>
+      <p:sp>
+        <p:nvSpPr>
+          <p:cNvPr id="22" name="TextBox 21"/>
+          <p:cNvSpPr txBox="1"/>
+          <p:nvPr/>
+        </p:nvSpPr>
+        <p:spPr>
+          <a:xfrm>
+            <a:off x="566928" y="3483864"/>
+            <a:ext cx="3749039" cy="228600"/>
+          </a:xfrm>
+          <a:prstGeom prst="rect">
+            <a:avLst/>
+          </a:prstGeom>
+          <a:noFill/>
+        </p:spPr>
+        <p:txBody>
+          <a:bodyPr wrap="square" lIns="0" rIns="0" tIns="0" bIns="0" anchor="t">
+            <a:spAutoFit/>
+          </a:bodyPr>
+          <a:lstStyle/>
+          <a:p>
+            <a:pPr algn="l"/>
+            <a:r>
+              <a:rPr sz="1150" b="1" i="0">
+                <a:solidFill>
+                  <a:srgbClr val="1B2630"/>
+                </a:solidFill>
+                <a:latin typeface="Open Sans"/>
+              </a:rPr>
+              <a:t>Correct</a:t>
+            </a:r>
+          </a:p>
+        </p:txBody>
+      </p:sp>
+      <p:sp>
+        <p:nvSpPr>
+          <p:cNvPr id="23" name="TextBox 22"/>
+          <p:cNvSpPr txBox="1"/>
+          <p:nvPr/>
+        </p:nvSpPr>
+        <p:spPr>
+          <a:xfrm>
+            <a:off x="566928" y="3721608"/>
+            <a:ext cx="3794760" cy="411480"/>
+          </a:xfrm>
+          <a:prstGeom prst="rect">
+            <a:avLst/>
+          </a:prstGeom>
+          <a:noFill/>
+        </p:spPr>
+        <p:txBody>
+          <a:bodyPr wrap="square" lIns="0" rIns="0" tIns="0" bIns="0" anchor="t">
+            <a:spAutoFit/>
+          </a:bodyPr>
+          <a:lstStyle/>
+          <a:p>
+            <a:pPr algn="l"/>
+            <a:r>
+              <a:rPr sz="950" b="0" i="0">
+                <a:solidFill>
+                  <a:srgbClr val="5A6875"/>
+                </a:solidFill>
+                <a:latin typeface="Open Sans"/>
+              </a:rPr>
+              <a:t>every result checked: max relative error ≤ 1e-4 vs a scalar reference / OpenCV's real outputs</a:t>
+            </a:r>
+          </a:p>
+        </p:txBody>
+      </p:sp>
+      <p:sp>
+        <p:nvSpPr>
+          <p:cNvPr id="24" name="assume-7"/>
+          <p:cNvSpPr/>
+          <p:nvPr/>
+        </p:nvSpPr>
+        <p:spPr>
+          <a:xfrm>
+            <a:off x="4617720" y="3419856"/>
+            <a:ext cx="4023360" cy="713232"/>
+          </a:xfrm>
+          <a:prstGeom prst="roundRect">
+            <a:avLst>
+              <a:gd name="adj" fmla="val 8000"/>
+            </a:avLst>
+          </a:prstGeom>
+          <a:solidFill>
+            <a:srgbClr val="F1F3F5"/>
+          </a:solidFill>
+          <a:ln>
+            <a:noFill/>
+          </a:ln>
+          <a:effectLst/>
+        </p:spPr>
+        <p:style>
+          <a:lnRef idx="1">
+            <a:schemeClr val="accent1"/>
+          </a:lnRef>
+          <a:fillRef idx="3">
+            <a:schemeClr val="accent1"/>
+          </a:fillRef>
+          <a:effectRef idx="2">
+            <a:schemeClr val="accent1"/>
+          </a:effectRef>
+          <a:fontRef idx="minor">
+            <a:schemeClr val="lt1"/>
+          </a:fontRef>
+        </p:style>
+        <p:txBody>
+          <a:bodyPr rtlCol="0" anchor="ctr"/>
+          <a:lstStyle/>
+          <a:p>
+            <a:pPr algn="ctr"/>
+          </a:p>
+        </p:txBody>
+      </p:sp>
+      <p:sp>
+        <p:nvSpPr>
+          <p:cNvPr id="25" name="TextBox 24"/>
+          <p:cNvSpPr txBox="1"/>
+          <p:nvPr/>
+        </p:nvSpPr>
+        <p:spPr>
+          <a:xfrm>
+            <a:off x="4727448" y="3483864"/>
+            <a:ext cx="3749039" cy="228600"/>
+          </a:xfrm>
+          <a:prstGeom prst="rect">
+            <a:avLst/>
+          </a:prstGeom>
+          <a:noFill/>
+        </p:spPr>
+        <p:txBody>
+          <a:bodyPr wrap="square" lIns="0" rIns="0" tIns="0" bIns="0" anchor="t">
+            <a:spAutoFit/>
+          </a:bodyPr>
+          <a:lstStyle/>
+          <a:p>
+            <a:pPr algn="l"/>
+            <a:r>
+              <a:rPr sz="1150" b="1" i="0">
+                <a:solidFill>
+                  <a:srgbClr val="1B2630"/>
+                </a:solidFill>
+                <a:latin typeface="Open Sans"/>
+              </a:rPr>
+              <a:t>Baseline</a:t>
+            </a:r>
+          </a:p>
+        </p:txBody>
+      </p:sp>
+      <p:sp>
+        <p:nvSpPr>
+          <p:cNvPr id="26" name="TextBox 25"/>
+          <p:cNvSpPr txBox="1"/>
+          <p:nvPr/>
+        </p:nvSpPr>
+        <p:spPr>
+          <a:xfrm>
+            <a:off x="4727448" y="3721608"/>
+            <a:ext cx="3794760" cy="411480"/>
+          </a:xfrm>
+          <a:prstGeom prst="rect">
+            <a:avLst/>
+          </a:prstGeom>
+          <a:noFill/>
+        </p:spPr>
+        <p:txBody>
+          <a:bodyPr wrap="square" lIns="0" rIns="0" tIns="0" bIns="0" anchor="t">
+            <a:spAutoFit/>
+          </a:bodyPr>
+          <a:lstStyle/>
+          <a:p>
+            <a:pPr algn="l"/>
+            <a:r>
+              <a:rPr sz="950" b="0" i="0">
+                <a:solidFill>
+                  <a:srgbClr val="5A6875"/>
+                </a:solidFill>
+                <a:latin typeface="Open Sans"/>
+              </a:rPr>
+              <a:t>OpenCV DNN on the same ONNX model, 1 thread, its own per-layer timer</a:t>
+            </a:r>
+          </a:p>
+        </p:txBody>
+      </p:sp>
+    </p:spTree>
+  </p:cSld>
+  <p:clrMapOvr>
+    <a:masterClrMapping/>
+  </p:clrMapOvr>
+</p:sld>
+</file>
+
+<file path=ppt/slides/slide5.xml><?xml version="1.0" encoding="utf-8"?>
 <p:sld xmlns:a="http://schemas.openxmlformats.org/drawingml/2006/main" xmlns:p="http://schemas.openxmlformats.org/presentationml/2006/main" xmlns:r="http://schemas.openxmlformats.org/officeDocument/2006/relationships">
   <p:cSld>
     <p:spTree>
@@ -8867,7 +10803,7 @@
 </p:sld>
 </file>
 
-<file path=ppt/slides/slide5.xml><?xml version="1.0" encoding="utf-8"?>
+<file path=ppt/slides/slide6.xml><?xml version="1.0" encoding="utf-8"?>
 <p:sld xmlns:a="http://schemas.openxmlformats.org/drawingml/2006/main" xmlns:p="http://schemas.openxmlformats.org/presentationml/2006/main" xmlns:r="http://schemas.openxmlformats.org/officeDocument/2006/relationships">
   <p:cSld>
     <p:spTree>
@@ -9011,8 +10947,8 @@
         </p:nvSpPr>
         <p:spPr>
           <a:xfrm>
-            <a:off x="6556248" y="1371600"/>
-            <a:ext cx="2011680" cy="548640"/>
+            <a:off x="6556248" y="1353312"/>
+            <a:ext cx="2011680" cy="594360"/>
           </a:xfrm>
           <a:prstGeom prst="rect">
             <a:avLst/>
@@ -9027,7 +10963,7 @@
           <a:p>
             <a:pPr algn="l"/>
             <a:r>
-              <a:rPr sz="1100" b="0" i="0">
+              <a:rPr sz="1000" b="0" i="0">
                 <a:solidFill>
                   <a:srgbClr val="5A6875"/>
                 </a:solidFill>
@@ -9127,8 +11063,8 @@
         </p:nvSpPr>
         <p:spPr>
           <a:xfrm>
-            <a:off x="6556248" y="2450592"/>
-            <a:ext cx="2011680" cy="548640"/>
+            <a:off x="6556248" y="2432304"/>
+            <a:ext cx="2011680" cy="594360"/>
           </a:xfrm>
           <a:prstGeom prst="rect">
             <a:avLst/>
@@ -9143,13 +11079,13 @@
           <a:p>
             <a:pPr algn="l"/>
             <a:r>
-              <a:rPr sz="1100" b="0" i="0">
+              <a:rPr sz="1000" b="0" i="0">
                 <a:solidFill>
                   <a:srgbClr val="5A6875"/>
                 </a:solidFill>
                 <a:latin typeface="Open Sans"/>
               </a:rPr>
-              <a:t>2×6 by hand: 95% alone, 84% in layers</a:t>
+              <a:t>hand-written CPU instructions, we pick every register: 2×6 at 95% alone, 84% in layers</a:t>
             </a:r>
           </a:p>
         </p:txBody>
@@ -9243,8 +11179,8 @@
         </p:nvSpPr>
         <p:spPr>
           <a:xfrm>
-            <a:off x="6556248" y="3529584"/>
-            <a:ext cx="2011680" cy="548640"/>
+            <a:off x="6556248" y="3511296"/>
+            <a:ext cx="2011680" cy="594360"/>
           </a:xfrm>
           <a:prstGeom prst="rect">
             <a:avLst/>
@@ -9259,321 +11195,13 @@
           <a:p>
             <a:pPr algn="l"/>
             <a:r>
-              <a:rPr sz="1100" b="0" i="0">
+              <a:rPr sz="1000" b="0" i="0">
                 <a:solidFill>
                   <a:srgbClr val="5A6875"/>
                 </a:solidFill>
                 <a:latin typeface="Open Sans"/>
               </a:rPr>
               <a:t>lost: uop cache, spills</a:t>
-            </a:r>
-          </a:p>
-        </p:txBody>
-      </p:sp>
-    </p:spTree>
-  </p:cSld>
-  <p:clrMapOvr>
-    <a:masterClrMapping/>
-  </p:clrMapOvr>
-</p:sld>
-</file>
-
-<file path=ppt/slides/slide6.xml><?xml version="1.0" encoding="utf-8"?>
-<p:sld xmlns:a="http://schemas.openxmlformats.org/drawingml/2006/main" xmlns:p="http://schemas.openxmlformats.org/presentationml/2006/main" xmlns:r="http://schemas.openxmlformats.org/officeDocument/2006/relationships">
-  <p:cSld>
-    <p:spTree>
-      <p:nvGrpSpPr>
-        <p:cNvPr id="1" name=""/>
-        <p:cNvGrpSpPr/>
-        <p:nvPr/>
-      </p:nvGrpSpPr>
-      <p:grpSpPr/>
-      <p:sp>
-        <p:nvSpPr>
-          <p:cNvPr id="2" name="Title 1"/>
-          <p:cNvSpPr>
-            <a:spLocks noGrp="1"/>
-          </p:cNvSpPr>
-          <p:nvPr>
-            <p:ph type="title"/>
-          </p:nvPr>
-        </p:nvSpPr>
-        <p:spPr/>
-        <p:txBody>
-          <a:bodyPr/>
-          <a:lstStyle/>
-          <a:p>
-            <a:r>
-              <a:t>Benchmarked like Assignment 2: FLOPs/cycle vs k</a:t>
-            </a:r>
-          </a:p>
-        </p:txBody>
-      </p:sp>
-      <p:pic>
-        <p:nvPicPr>
-          <p:cNvPr id="3" name="Picture 2" descr="ukr_sweep_nosilu_34.png"/>
-          <p:cNvPicPr>
-            <a:picLocks noChangeAspect="1"/>
-          </p:cNvPicPr>
-          <p:nvPr/>
-        </p:nvPicPr>
-        <p:blipFill>
-          <a:blip r:embed="rId3"/>
-          <a:stretch>
-            <a:fillRect/>
-          </a:stretch>
-        </p:blipFill>
-        <p:spPr>
-          <a:xfrm>
-            <a:off x="457200" y="960120"/>
-            <a:ext cx="5486400" cy="2926080"/>
-          </a:xfrm>
-          <a:prstGeom prst="rect">
-            <a:avLst/>
-          </a:prstGeom>
-        </p:spPr>
-      </p:pic>
-      <p:sp>
-        <p:nvSpPr>
-          <p:cNvPr id="4" name="TextBox 3"/>
-          <p:cNvSpPr txBox="1"/>
-          <p:nvPr/>
-        </p:nvSpPr>
-        <p:spPr>
-          <a:xfrm>
-            <a:off x="457200" y="3931920"/>
-            <a:ext cx="5486400" cy="274320"/>
-          </a:xfrm>
-          <a:prstGeom prst="rect">
-            <a:avLst/>
-          </a:prstGeom>
-          <a:noFill/>
-        </p:spPr>
-        <p:txBody>
-          <a:bodyPr wrap="square" lIns="0" rIns="0" tIns="0" bIns="0" anchor="t">
-            <a:spAutoFit/>
-          </a:bodyPr>
-          <a:lstStyle/>
-          <a:p>
-            <a:pPr algn="l"/>
-            <a:r>
-              <a:rPr sz="1000" b="0" i="0">
-                <a:solidFill>
-                  <a:srgbClr val="5A6875"/>
-                </a:solidFill>
-                <a:latin typeface="Open Sans"/>
-              </a:rPr>
-              <a:t>SiLU off, cycles = time × 3.4 GHz, as in A2. 3 runs, every point checked (576 pass).</a:t>
-            </a:r>
-          </a:p>
-        </p:txBody>
-      </p:sp>
-      <p:sp>
-        <p:nvSpPr>
-          <p:cNvPr id="5" name="TextBox 4"/>
-          <p:cNvSpPr txBox="1"/>
-          <p:nvPr/>
-        </p:nvSpPr>
-        <p:spPr>
-          <a:xfrm>
-            <a:off x="6172200" y="960120"/>
-            <a:ext cx="2514600" cy="548640"/>
-          </a:xfrm>
-          <a:prstGeom prst="rect">
-            <a:avLst/>
-          </a:prstGeom>
-          <a:noFill/>
-        </p:spPr>
-        <p:txBody>
-          <a:bodyPr wrap="square" lIns="0" rIns="0" tIns="0" bIns="0" anchor="t">
-            <a:spAutoFit/>
-          </a:bodyPr>
-          <a:lstStyle/>
-          <a:p>
-            <a:pPr algn="l"/>
-            <a:r>
-              <a:rPr sz="3000" b="1" i="0">
-                <a:solidFill>
-                  <a:srgbClr val="BB0027"/>
-                </a:solidFill>
-                <a:latin typeface="Open Sans"/>
-              </a:rPr>
-              <a:t>94–97%</a:t>
-            </a:r>
-          </a:p>
-        </p:txBody>
-      </p:sp>
-      <p:sp>
-        <p:nvSpPr>
-          <p:cNvPr id="6" name="TextBox 5"/>
-          <p:cNvSpPr txBox="1"/>
-          <p:nvPr/>
-        </p:nvSpPr>
-        <p:spPr>
-          <a:xfrm>
-            <a:off x="6172200" y="1527048"/>
-            <a:ext cx="2514600" cy="548640"/>
-          </a:xfrm>
-          <a:prstGeom prst="rect">
-            <a:avLst/>
-          </a:prstGeom>
-          <a:noFill/>
-        </p:spPr>
-        <p:txBody>
-          <a:bodyPr wrap="square" lIns="0" rIns="0" tIns="0" bIns="0" anchor="t">
-            <a:spAutoFit/>
-          </a:bodyPr>
-          <a:lstStyle/>
-          <a:p>
-            <a:pPr algn="l"/>
-            <a:r>
-              <a:rPr sz="1200" b="0" i="0">
-                <a:solidFill>
-                  <a:srgbClr val="5A6875"/>
-                </a:solidFill>
-                <a:latin typeface="Open Sans"/>
-              </a:rPr>
-              <a:t>2×6 asm: 30–31 FLOPs/cycle, ~102 GFLOP/s on one core</a:t>
-            </a:r>
-          </a:p>
-        </p:txBody>
-      </p:sp>
-      <p:sp>
-        <p:nvSpPr>
-          <p:cNvPr id="7" name="TextBox 6"/>
-          <p:cNvSpPr txBox="1"/>
-          <p:nvPr/>
-        </p:nvSpPr>
-        <p:spPr>
-          <a:xfrm>
-            <a:off x="6172200" y="2011680"/>
-            <a:ext cx="2514600" cy="548640"/>
-          </a:xfrm>
-          <a:prstGeom prst="rect">
-            <a:avLst/>
-          </a:prstGeom>
-          <a:noFill/>
-        </p:spPr>
-        <p:txBody>
-          <a:bodyPr wrap="square" lIns="0" rIns="0" tIns="0" bIns="0" anchor="t">
-            <a:spAutoFit/>
-          </a:bodyPr>
-          <a:lstStyle/>
-          <a:p>
-            <a:pPr algn="l"/>
-            <a:r>
-              <a:rPr sz="3000" b="1" i="0">
-                <a:solidFill>
-                  <a:srgbClr val="6B7782"/>
-                </a:solidFill>
-                <a:latin typeface="Open Sans"/>
-              </a:rPr>
-              <a:t>83–89%</a:t>
-            </a:r>
-          </a:p>
-        </p:txBody>
-      </p:sp>
-      <p:sp>
-        <p:nvSpPr>
-          <p:cNvPr id="8" name="TextBox 7"/>
-          <p:cNvSpPr txBox="1"/>
-          <p:nvPr/>
-        </p:nvSpPr>
-        <p:spPr>
-          <a:xfrm>
-            <a:off x="6172200" y="2578608"/>
-            <a:ext cx="2514600" cy="548640"/>
-          </a:xfrm>
-          <a:prstGeom prst="rect">
-            <a:avLst/>
-          </a:prstGeom>
-          <a:noFill/>
-        </p:spPr>
-        <p:txBody>
-          <a:bodyPr wrap="square" lIns="0" rIns="0" tIns="0" bIns="0" anchor="t">
-            <a:spAutoFit/>
-          </a:bodyPr>
-          <a:lstStyle/>
-          <a:p>
-            <a:pPr algn="l"/>
-            <a:r>
-              <a:rPr sz="1200" b="0" i="0">
-                <a:solidFill>
-                  <a:srgbClr val="5A6875"/>
-                </a:solidFill>
-                <a:latin typeface="Open Sans"/>
-              </a:rPr>
-              <a:t>2×5 intrinsics (v2's tile)</a:t>
-            </a:r>
-          </a:p>
-        </p:txBody>
-      </p:sp>
-      <p:sp>
-        <p:nvSpPr>
-          <p:cNvPr id="9" name="TextBox 8"/>
-          <p:cNvSpPr txBox="1"/>
-          <p:nvPr/>
-        </p:nvSpPr>
-        <p:spPr>
-          <a:xfrm>
-            <a:off x="6172200" y="3063240"/>
-            <a:ext cx="2514600" cy="548640"/>
-          </a:xfrm>
-          <a:prstGeom prst="rect">
-            <a:avLst/>
-          </a:prstGeom>
-          <a:noFill/>
-        </p:spPr>
-        <p:txBody>
-          <a:bodyPr wrap="square" lIns="0" rIns="0" tIns="0" bIns="0" anchor="t">
-            <a:spAutoFit/>
-          </a:bodyPr>
-          <a:lstStyle/>
-          <a:p>
-            <a:pPr algn="l"/>
-            <a:r>
-              <a:rPr sz="3000" b="1" i="0">
-                <a:solidFill>
-                  <a:srgbClr val="B7731A"/>
-                </a:solidFill>
-                <a:latin typeface="Open Sans"/>
-              </a:rPr>
-              <a:t>k ≈ 500</a:t>
-            </a:r>
-          </a:p>
-        </p:txBody>
-      </p:sp>
-      <p:sp>
-        <p:nvSpPr>
-          <p:cNvPr id="10" name="TextBox 9"/>
-          <p:cNvSpPr txBox="1"/>
-          <p:nvPr/>
-        </p:nvSpPr>
-        <p:spPr>
-          <a:xfrm>
-            <a:off x="6172200" y="3630168"/>
-            <a:ext cx="2514600" cy="548640"/>
-          </a:xfrm>
-          <a:prstGeom prst="rect">
-            <a:avLst/>
-          </a:prstGeom>
-          <a:noFill/>
-        </p:spPr>
-        <p:txBody>
-          <a:bodyPr wrap="square" lIns="0" rIns="0" tIns="0" bIns="0" anchor="t">
-            <a:spAutoFit/>
-          </a:bodyPr>
-          <a:lstStyle/>
-          <a:p>
-            <a:pPr algn="l"/>
-            <a:r>
-              <a:rPr sz="1200" b="0" i="0">
-                <a:solidFill>
-                  <a:srgbClr val="5A6875"/>
-                </a:solidFill>
-                <a:latin typeface="Open Sans"/>
-              </a:rPr>
-              <a:t>L1 dip: 2×5 weights pass 32 KB, like k ≈ 315 in A2</a:t>
             </a:r>
           </a:p>
         </p:txBody>
@@ -9612,21 +11240,45 @@
           <a:lstStyle/>
           <a:p>
             <a:r>
-              <a:t>Alone vs in a layer: keep the kernel a function</a:t>
+              <a:t>Benchmarked like Assignment 2: FLOPs/cycle vs k</a:t>
             </a:r>
           </a:p>
         </p:txBody>
       </p:sp>
-      <p:sp>
-        <p:nvSpPr>
-          <p:cNvPr id="3" name="TextBox 2"/>
+      <p:pic>
+        <p:nvPicPr>
+          <p:cNvPr id="3" name="Picture 2" descr="ukr_sweep_nosilu_34.png"/>
+          <p:cNvPicPr>
+            <a:picLocks noChangeAspect="1"/>
+          </p:cNvPicPr>
+          <p:nvPr/>
+        </p:nvPicPr>
+        <p:blipFill>
+          <a:blip r:embed="rId3"/>
+          <a:stretch>
+            <a:fillRect/>
+          </a:stretch>
+        </p:blipFill>
+        <p:spPr>
+          <a:xfrm>
+            <a:off x="457200" y="960120"/>
+            <a:ext cx="5486400" cy="2926080"/>
+          </a:xfrm>
+          <a:prstGeom prst="rect">
+            <a:avLst/>
+          </a:prstGeom>
+        </p:spPr>
+      </p:pic>
+      <p:sp>
+        <p:nvSpPr>
+          <p:cNvPr id="4" name="TextBox 3"/>
           <p:cNvSpPr txBox="1"/>
           <p:nvPr/>
         </p:nvSpPr>
         <p:spPr>
           <a:xfrm>
-            <a:off x="457200" y="1005840"/>
-            <a:ext cx="4206240" cy="502920"/>
+            <a:off x="457200" y="3931920"/>
+            <a:ext cx="5486400" cy="274320"/>
           </a:xfrm>
           <a:prstGeom prst="rect">
             <a:avLst/>
@@ -9641,60 +11293,14 @@
           <a:p>
             <a:pPr algn="l"/>
             <a:r>
-              <a:rPr sz="1300" b="1" i="0">
-                <a:solidFill>
-                  <a:srgbClr val="1B2630"/>
+              <a:rPr sz="1000" b="0" i="0">
+                <a:solidFill>
+                  <a:srgbClr val="5A6875"/>
                 </a:solidFill>
                 <a:latin typeface="Open Sans"/>
               </a:rPr>
-              <a:t>v2a (2×5 asm): 92.2% alone, 72.5% when GCC inlines it into the layer loop</a:t>
+              <a:t>SiLU off, cycles = time × 3.4 GHz, as in A2. 3 runs, every point checked (576 pass).</a:t>
             </a:r>
-          </a:p>
-        </p:txBody>
-      </p:sp>
-      <p:sp>
-        <p:nvSpPr>
-          <p:cNvPr id="4" name="spill-code"/>
-          <p:cNvSpPr/>
-          <p:nvPr/>
-        </p:nvSpPr>
-        <p:spPr>
-          <a:xfrm>
-            <a:off x="457200" y="1600200"/>
-            <a:ext cx="4206240" cy="868680"/>
-          </a:xfrm>
-          <a:prstGeom prst="roundRect">
-            <a:avLst>
-              <a:gd name="adj" fmla="val 8000"/>
-            </a:avLst>
-          </a:prstGeom>
-          <a:solidFill>
-            <a:srgbClr val="F1F3F5"/>
-          </a:solidFill>
-          <a:ln>
-            <a:noFill/>
-          </a:ln>
-          <a:effectLst/>
-        </p:spPr>
-        <p:style>
-          <a:lnRef idx="1">
-            <a:schemeClr val="accent1"/>
-          </a:lnRef>
-          <a:fillRef idx="3">
-            <a:schemeClr val="accent1"/>
-          </a:fillRef>
-          <a:effectRef idx="2">
-            <a:schemeClr val="accent1"/>
-          </a:effectRef>
-          <a:fontRef idx="minor">
-            <a:schemeClr val="lt1"/>
-          </a:fontRef>
-        </p:style>
-        <p:txBody>
-          <a:bodyPr rtlCol="0" anchor="ctr"/>
-          <a:lstStyle/>
-          <a:p>
-            <a:pPr algn="ctr"/>
           </a:p>
         </p:txBody>
       </p:sp>
@@ -9706,8 +11312,8 @@
         </p:nvSpPr>
         <p:spPr>
           <a:xfrm>
-            <a:off x="566928" y="1664208"/>
-            <a:ext cx="4023360" cy="749808"/>
+            <a:off x="6172200" y="960120"/>
+            <a:ext cx="2514600" cy="548640"/>
           </a:xfrm>
           <a:prstGeom prst="rect">
             <a:avLst/>
@@ -9715,52 +11321,20 @@
           <a:noFill/>
         </p:spPr>
         <p:txBody>
-          <a:bodyPr wrap="square" lIns="0" rIns="0" tIns="0" bIns="0" anchor="ctr">
+          <a:bodyPr wrap="square" lIns="0" rIns="0" tIns="0" bIns="0" anchor="t">
             <a:spAutoFit/>
           </a:bodyPr>
           <a:lstStyle/>
           <a:p>
             <a:pPr algn="l"/>
             <a:r>
-              <a:rPr sz="1050" b="0" i="0">
-                <a:solidFill>
-                  <a:srgbClr val="1B2630"/>
-                </a:solidFill>
-                <a:latin typeface="Courier New"/>
+              <a:rPr sz="3000" b="1" i="0">
+                <a:solidFill>
+                  <a:srgbClr val="BB0027"/>
+                </a:solidFill>
+                <a:latin typeface="Open Sans"/>
               </a:rPr>
-              <a:t>vmovaps 168(%rsp), %ymm1   # reload acc</a:t>
-            </a:r>
-          </a:p>
-          <a:p>
-            <a:pPr algn="l">
-              <a:spcBef>
-                <a:spcPts val="600"/>
-              </a:spcBef>
-            </a:pPr>
-            <a:r>
-              <a:rPr sz="1050" b="0" i="0">
-                <a:solidFill>
-                  <a:srgbClr val="1B2630"/>
-                </a:solidFill>
-                <a:latin typeface="Courier New"/>
-              </a:rPr>
-              <a:t>  ...asm block: 80 FMAs...</a:t>
-            </a:r>
-          </a:p>
-          <a:p>
-            <a:pPr algn="l">
-              <a:spcBef>
-                <a:spcPts val="600"/>
-              </a:spcBef>
-            </a:pPr>
-            <a:r>
-              <a:rPr sz="1050" b="0" i="0">
-                <a:solidFill>
-                  <a:srgbClr val="1B2630"/>
-                </a:solidFill>
-                <a:latin typeface="Courier New"/>
-              </a:rPr>
-              <a:t>vmovaps %ymm1, 168(%rsp)   # store acc</a:t>
+              <a:t>94–97%</a:t>
             </a:r>
           </a:p>
         </p:txBody>
@@ -9773,8 +11347,8 @@
         </p:nvSpPr>
         <p:spPr>
           <a:xfrm>
-            <a:off x="457200" y="2578608"/>
-            <a:ext cx="4206240" cy="777240"/>
+            <a:off x="6172200" y="1527048"/>
+            <a:ext cx="2514600" cy="548640"/>
           </a:xfrm>
           <a:prstGeom prst="rect">
             <a:avLst/>
@@ -9789,13 +11363,13 @@
           <a:p>
             <a:pPr algn="l"/>
             <a:r>
-              <a:rPr sz="1150" b="0" i="0">
+              <a:rPr sz="1200" b="0" i="0">
                 <a:solidFill>
                   <a:srgbClr val="5A6875"/>
                 </a:solidFill>
                 <a:latin typeface="Open Sans"/>
               </a:rPr>
-              <a:t>Inlined, GCC keeps 3 of 10 accumulators on the stack around every tap. Called as a function, as in the benchmark: 83.1% (v2b); with the 2×6 tile, 83.7% (v10).</a:t>
+              <a:t>2×6 asm: 30–31 FLOPs/cycle, ~102 GFLOP/s on one core</a:t>
             </a:r>
           </a:p>
         </p:txBody>
@@ -9808,8 +11382,8 @@
         </p:nvSpPr>
         <p:spPr>
           <a:xfrm>
-            <a:off x="457200" y="3474720"/>
-            <a:ext cx="4206240" cy="685800"/>
+            <a:off x="6172200" y="2011680"/>
+            <a:ext cx="2514600" cy="548640"/>
           </a:xfrm>
           <a:prstGeom prst="rect">
             <a:avLst/>
@@ -9824,35 +11398,122 @@
           <a:p>
             <a:pPr algn="l"/>
             <a:r>
-              <a:rPr sz="1150" b="0" i="1">
-                <a:solidFill>
-                  <a:srgbClr val="BB0027"/>
+              <a:rPr sz="3000" b="1" i="0">
+                <a:solidFill>
+                  <a:srgbClr val="6B7782"/>
                 </a:solidFill>
                 <a:latin typeface="Open Sans"/>
               </a:rPr>
-              <a:t>Next: cache blocking for C ≥ 128 (the 4×3 drop-off), NUMA-aware threads (v10 on 20 cores: 4.74 ms).</a:t>
+              <a:t>83–89%</a:t>
             </a:r>
           </a:p>
         </p:txBody>
       </p:sp>
-      <p:graphicFrame>
-        <p:nvGraphicFramePr>
-          <p:cNvPr id="8" name="Chart 7"/>
-          <p:cNvGraphicFramePr>
-            <a:graphicFrameLocks noGrp="1"/>
-          </p:cNvGraphicFramePr>
+      <p:sp>
+        <p:nvSpPr>
+          <p:cNvPr id="8" name="TextBox 7"/>
+          <p:cNvSpPr txBox="1"/>
           <p:nvPr/>
-        </p:nvGraphicFramePr>
-        <p:xfrm>
-          <a:off x="4846320" y="960120"/>
-          <a:ext cx="3840480" cy="3246120"/>
-        </p:xfrm>
-        <a:graphic>
-          <a:graphicData uri="http://schemas.openxmlformats.org/drawingml/2006/chart">
-            <c:chart xmlns:c="http://schemas.openxmlformats.org/drawingml/2006/chart" r:id="rId3"/>
-          </a:graphicData>
-        </a:graphic>
-      </p:graphicFrame>
+        </p:nvSpPr>
+        <p:spPr>
+          <a:xfrm>
+            <a:off x="6172200" y="2578608"/>
+            <a:ext cx="2514600" cy="548640"/>
+          </a:xfrm>
+          <a:prstGeom prst="rect">
+            <a:avLst/>
+          </a:prstGeom>
+          <a:noFill/>
+        </p:spPr>
+        <p:txBody>
+          <a:bodyPr wrap="square" lIns="0" rIns="0" tIns="0" bIns="0" anchor="t">
+            <a:spAutoFit/>
+          </a:bodyPr>
+          <a:lstStyle/>
+          <a:p>
+            <a:pPr algn="l"/>
+            <a:r>
+              <a:rPr sz="1200" b="0" i="0">
+                <a:solidFill>
+                  <a:srgbClr val="5A6875"/>
+                </a:solidFill>
+                <a:latin typeface="Open Sans"/>
+              </a:rPr>
+              <a:t>2×5 intrinsics (v2's tile)</a:t>
+            </a:r>
+          </a:p>
+        </p:txBody>
+      </p:sp>
+      <p:sp>
+        <p:nvSpPr>
+          <p:cNvPr id="9" name="TextBox 8"/>
+          <p:cNvSpPr txBox="1"/>
+          <p:nvPr/>
+        </p:nvSpPr>
+        <p:spPr>
+          <a:xfrm>
+            <a:off x="6172200" y="3063240"/>
+            <a:ext cx="2514600" cy="548640"/>
+          </a:xfrm>
+          <a:prstGeom prst="rect">
+            <a:avLst/>
+          </a:prstGeom>
+          <a:noFill/>
+        </p:spPr>
+        <p:txBody>
+          <a:bodyPr wrap="square" lIns="0" rIns="0" tIns="0" bIns="0" anchor="t">
+            <a:spAutoFit/>
+          </a:bodyPr>
+          <a:lstStyle/>
+          <a:p>
+            <a:pPr algn="l"/>
+            <a:r>
+              <a:rPr sz="3000" b="1" i="0">
+                <a:solidFill>
+                  <a:srgbClr val="B7731A"/>
+                </a:solidFill>
+                <a:latin typeface="Open Sans"/>
+              </a:rPr>
+              <a:t>k ≈ 500</a:t>
+            </a:r>
+          </a:p>
+        </p:txBody>
+      </p:sp>
+      <p:sp>
+        <p:nvSpPr>
+          <p:cNvPr id="10" name="TextBox 9"/>
+          <p:cNvSpPr txBox="1"/>
+          <p:nvPr/>
+        </p:nvSpPr>
+        <p:spPr>
+          <a:xfrm>
+            <a:off x="6172200" y="3630168"/>
+            <a:ext cx="2514600" cy="548640"/>
+          </a:xfrm>
+          <a:prstGeom prst="rect">
+            <a:avLst/>
+          </a:prstGeom>
+          <a:noFill/>
+        </p:spPr>
+        <p:txBody>
+          <a:bodyPr wrap="square" lIns="0" rIns="0" tIns="0" bIns="0" anchor="t">
+            <a:spAutoFit/>
+          </a:bodyPr>
+          <a:lstStyle/>
+          <a:p>
+            <a:pPr algn="l"/>
+            <a:r>
+              <a:rPr sz="1200" b="0" i="0">
+                <a:solidFill>
+                  <a:srgbClr val="5A6875"/>
+                </a:solidFill>
+                <a:latin typeface="Open Sans"/>
+              </a:rPr>
+              <a:t>L1 dip: 2×5 weights pass 32 KB, like k ≈ 315 in A2</a:t>
+            </a:r>
+          </a:p>
+        </p:txBody>
+      </p:sp>
     </p:spTree>
   </p:cSld>
   <p:clrMapOvr>
@@ -9887,59 +11548,373 @@
           <a:lstStyle/>
           <a:p>
             <a:r>
-              <a:t>Backup: the same sweeps with SiLU on</a:t>
+              <a:t>Fastest alone is not fastest in the layer</a:t>
             </a:r>
           </a:p>
         </p:txBody>
       </p:sp>
-      <p:pic>
-        <p:nvPicPr>
-          <p:cNvPr id="3" name="Picture 2" descr="ukr_sweep_2x6_34.png"/>
-          <p:cNvPicPr>
-            <a:picLocks noChangeAspect="1"/>
-          </p:cNvPicPr>
+      <p:graphicFrame>
+        <p:nvGraphicFramePr>
+          <p:cNvPr id="3" name="Chart 2"/>
+          <p:cNvGraphicFramePr>
+            <a:graphicFrameLocks noGrp="1"/>
+          </p:cNvGraphicFramePr>
           <p:nvPr/>
-        </p:nvPicPr>
-        <p:blipFill>
-          <a:blip r:embed="rId3"/>
-          <a:stretch>
-            <a:fillRect/>
-          </a:stretch>
-        </p:blipFill>
-        <p:spPr>
-          <a:xfrm>
-            <a:off x="457200" y="1051560"/>
-            <a:ext cx="4023360" cy="2145792"/>
+        </p:nvGraphicFramePr>
+        <p:xfrm>
+          <a:off x="457200" y="1005840"/>
+          <a:ext cx="4023360" cy="3200400"/>
+        </p:xfrm>
+        <a:graphic>
+          <a:graphicData uri="http://schemas.openxmlformats.org/drawingml/2006/chart">
+            <c:chart xmlns:c="http://schemas.openxmlformats.org/drawingml/2006/chart" r:id="rId3"/>
+          </a:graphicData>
+        </a:graphic>
+      </p:graphicFrame>
+      <p:sp>
+        <p:nvSpPr>
+          <p:cNvPr id="4" name="TextBox 3"/>
+          <p:cNvSpPr txBox="1"/>
+          <p:nvPr/>
+        </p:nvSpPr>
+        <p:spPr>
+          <a:xfrm>
+            <a:off x="4754880" y="1005840"/>
+            <a:ext cx="3931920" cy="274320"/>
           </a:xfrm>
           <a:prstGeom prst="rect">
             <a:avLst/>
           </a:prstGeom>
-        </p:spPr>
-      </p:pic>
-      <p:pic>
-        <p:nvPicPr>
-          <p:cNvPr id="4" name="Picture 3" descr="ukr_sweep_34.png"/>
-          <p:cNvPicPr>
-            <a:picLocks noChangeAspect="1"/>
-          </p:cNvPicPr>
+          <a:noFill/>
+        </p:spPr>
+        <p:txBody>
+          <a:bodyPr wrap="square" lIns="0" rIns="0" tIns="0" bIns="0" anchor="t">
+            <a:spAutoFit/>
+          </a:bodyPr>
+          <a:lstStyle/>
+          <a:p>
+            <a:pPr algn="l"/>
+            <a:r>
+              <a:rPr sz="1200" b="1" i="0">
+                <a:solidFill>
+                  <a:srgbClr val="1B2630"/>
+                </a:solidFill>
+                <a:latin typeface="Open Sans"/>
+              </a:rPr>
+              <a:t>What the compiler did when inlined:</a:t>
+            </a:r>
+          </a:p>
+        </p:txBody>
+      </p:sp>
+      <p:sp>
+        <p:nvSpPr>
+          <p:cNvPr id="5" name="spill-code"/>
+          <p:cNvSpPr/>
           <p:nvPr/>
-        </p:nvPicPr>
-        <p:blipFill>
-          <a:blip r:embed="rId4"/>
-          <a:stretch>
-            <a:fillRect/>
-          </a:stretch>
-        </p:blipFill>
-        <p:spPr>
-          <a:xfrm>
-            <a:off x="4663440" y="1051560"/>
-            <a:ext cx="4023360" cy="2145792"/>
+        </p:nvSpPr>
+        <p:spPr>
+          <a:xfrm>
+            <a:off x="4754880" y="1325880"/>
+            <a:ext cx="3931920" cy="868680"/>
+          </a:xfrm>
+          <a:prstGeom prst="roundRect">
+            <a:avLst>
+              <a:gd name="adj" fmla="val 8000"/>
+            </a:avLst>
+          </a:prstGeom>
+          <a:solidFill>
+            <a:srgbClr val="F1F3F5"/>
+          </a:solidFill>
+          <a:ln>
+            <a:noFill/>
+          </a:ln>
+          <a:effectLst/>
+        </p:spPr>
+        <p:style>
+          <a:lnRef idx="1">
+            <a:schemeClr val="accent1"/>
+          </a:lnRef>
+          <a:fillRef idx="3">
+            <a:schemeClr val="accent1"/>
+          </a:fillRef>
+          <a:effectRef idx="2">
+            <a:schemeClr val="accent1"/>
+          </a:effectRef>
+          <a:fontRef idx="minor">
+            <a:schemeClr val="lt1"/>
+          </a:fontRef>
+        </p:style>
+        <p:txBody>
+          <a:bodyPr rtlCol="0" anchor="ctr"/>
+          <a:lstStyle/>
+          <a:p>
+            <a:pPr algn="ctr"/>
+          </a:p>
+        </p:txBody>
+      </p:sp>
+      <p:sp>
+        <p:nvSpPr>
+          <p:cNvPr id="6" name="TextBox 5"/>
+          <p:cNvSpPr txBox="1"/>
+          <p:nvPr/>
+        </p:nvSpPr>
+        <p:spPr>
+          <a:xfrm>
+            <a:off x="4864608" y="1389888"/>
+            <a:ext cx="3749039" cy="749808"/>
           </a:xfrm>
           <a:prstGeom prst="rect">
             <a:avLst/>
           </a:prstGeom>
-        </p:spPr>
-      </p:pic>
+          <a:noFill/>
+        </p:spPr>
+        <p:txBody>
+          <a:bodyPr wrap="square" lIns="0" rIns="0" tIns="0" bIns="0" anchor="ctr">
+            <a:spAutoFit/>
+          </a:bodyPr>
+          <a:lstStyle/>
+          <a:p>
+            <a:pPr algn="l"/>
+            <a:r>
+              <a:rPr sz="1050" b="0" i="0">
+                <a:solidFill>
+                  <a:srgbClr val="1B2630"/>
+                </a:solidFill>
+                <a:latin typeface="Courier New"/>
+              </a:rPr>
+              <a:t>vmovaps 168(%rsp), %ymm1   # load sum back</a:t>
+            </a:r>
+          </a:p>
+          <a:p>
+            <a:pPr algn="l">
+              <a:spcBef>
+                <a:spcPts val="600"/>
+              </a:spcBef>
+            </a:pPr>
+            <a:r>
+              <a:rPr sz="1050" b="0" i="0">
+                <a:solidFill>
+                  <a:srgbClr val="1B2630"/>
+                </a:solidFill>
+                <a:latin typeface="Courier New"/>
+              </a:rPr>
+              <a:t>  ...kernel: 80 FMAs...</a:t>
+            </a:r>
+          </a:p>
+          <a:p>
+            <a:pPr algn="l">
+              <a:spcBef>
+                <a:spcPts val="600"/>
+              </a:spcBef>
+            </a:pPr>
+            <a:r>
+              <a:rPr sz="1050" b="0" i="0">
+                <a:solidFill>
+                  <a:srgbClr val="1B2630"/>
+                </a:solidFill>
+                <a:latin typeface="Courier New"/>
+              </a:rPr>
+              <a:t>vmovaps %ymm1, 168(%rsp)   # park sum again</a:t>
+            </a:r>
+          </a:p>
+        </p:txBody>
+      </p:sp>
+      <p:sp>
+        <p:nvSpPr>
+          <p:cNvPr id="7" name="TextBox 6"/>
+          <p:cNvSpPr txBox="1"/>
+          <p:nvPr/>
+        </p:nvSpPr>
+        <p:spPr>
+          <a:xfrm>
+            <a:off x="4754880" y="2331720"/>
+            <a:ext cx="3931920" cy="914400"/>
+          </a:xfrm>
+          <a:prstGeom prst="rect">
+            <a:avLst/>
+          </a:prstGeom>
+          <a:noFill/>
+        </p:spPr>
+        <p:txBody>
+          <a:bodyPr wrap="square" lIns="0" rIns="0" tIns="0" bIns="0" anchor="t">
+            <a:spAutoFit/>
+          </a:bodyPr>
+          <a:lstStyle/>
+          <a:p>
+            <a:pPr algn="l"/>
+            <a:r>
+              <a:rPr sz="1150" b="1" i="0">
+                <a:solidFill>
+                  <a:srgbClr val="1B2630"/>
+                </a:solidFill>
+                <a:latin typeface="Open Sans"/>
+              </a:rPr>
+              <a:t>Problem: </a:t>
+            </a:r>
+            <a:r>
+              <a:rPr sz="1150" b="0" i="0">
+                <a:solidFill>
+                  <a:srgbClr val="5A6875"/>
+                </a:solidFill>
+                <a:latin typeface="Open Sans"/>
+              </a:rPr>
+              <a:t>3 of the 10 sums live in memory, so each step waits on a store and a load.</a:t>
+            </a:r>
+          </a:p>
+          <a:p>
+            <a:pPr algn="l">
+              <a:spcBef>
+                <a:spcPts val="600"/>
+              </a:spcBef>
+            </a:pPr>
+            <a:r>
+              <a:rPr sz="1150" b="1" i="0">
+                <a:solidFill>
+                  <a:srgbClr val="1B2630"/>
+                </a:solidFill>
+                <a:latin typeface="Open Sans"/>
+              </a:rPr>
+              <a:t>Fix: </a:t>
+            </a:r>
+            <a:r>
+              <a:rPr sz="1150" b="0" i="0">
+                <a:solidFill>
+                  <a:srgbClr val="5A6875"/>
+                </a:solidFill>
+                <a:latin typeface="Open Sans"/>
+              </a:rPr>
+              <a:t>call the kernel as a function, as the benchmark does; all 10 stay in registers.</a:t>
+            </a:r>
+          </a:p>
+        </p:txBody>
+      </p:sp>
+      <p:sp>
+        <p:nvSpPr>
+          <p:cNvPr id="8" name="TextBox 7"/>
+          <p:cNvSpPr txBox="1"/>
+          <p:nvPr/>
+        </p:nvSpPr>
+        <p:spPr>
+          <a:xfrm>
+            <a:off x="4754880" y="3429000"/>
+            <a:ext cx="3931920" cy="731520"/>
+          </a:xfrm>
+          <a:prstGeom prst="rect">
+            <a:avLst/>
+          </a:prstGeom>
+          <a:noFill/>
+        </p:spPr>
+        <p:txBody>
+          <a:bodyPr wrap="square" lIns="0" rIns="0" tIns="0" bIns="0" anchor="t">
+            <a:spAutoFit/>
+          </a:bodyPr>
+          <a:lstStyle/>
+          <a:p>
+            <a:pPr algn="l"/>
+            <a:r>
+              <a:rPr sz="1400" b="1" i="1">
+                <a:solidFill>
+                  <a:srgbClr val="BB0027"/>
+                </a:solidFill>
+                <a:latin typeface="Open Sans"/>
+              </a:rPr>
+              <a:t>The kernel is only fast if its registers stay its own.</a:t>
+            </a:r>
+          </a:p>
+        </p:txBody>
+      </p:sp>
+    </p:spTree>
+  </p:cSld>
+  <p:clrMapOvr>
+    <a:masterClrMapping/>
+  </p:clrMapOvr>
+</p:sld>
+</file>
+
+<file path=ppt/slides/slide9.xml><?xml version="1.0" encoding="utf-8"?>
+<p:sld xmlns:a="http://schemas.openxmlformats.org/drawingml/2006/main" xmlns:p="http://schemas.openxmlformats.org/presentationml/2006/main" xmlns:r="http://schemas.openxmlformats.org/officeDocument/2006/relationships">
+  <p:cSld>
+    <p:spTree>
+      <p:nvGrpSpPr>
+        <p:cNvPr id="1" name=""/>
+        <p:cNvGrpSpPr/>
+        <p:nvPr/>
+      </p:nvGrpSpPr>
+      <p:grpSpPr/>
+      <p:sp>
+        <p:nvSpPr>
+          <p:cNvPr id="2" name="Title 1"/>
+          <p:cNvSpPr>
+            <a:spLocks noGrp="1"/>
+          </p:cNvSpPr>
+          <p:nvPr>
+            <p:ph type="title"/>
+          </p:nvPr>
+        </p:nvSpPr>
+        <p:spPr/>
+        <p:txBody>
+          <a:bodyPr/>
+          <a:lstStyle/>
+          <a:p>
+            <a:r>
+              <a:t>1.36× faster than OpenCV on all 32 layers</a:t>
+            </a:r>
+          </a:p>
+        </p:txBody>
+      </p:sp>
+      <p:graphicFrame>
+        <p:nvGraphicFramePr>
+          <p:cNvPr id="3" name="Chart 2"/>
+          <p:cNvGraphicFramePr>
+            <a:graphicFrameLocks noGrp="1"/>
+          </p:cNvGraphicFramePr>
+          <p:nvPr/>
+        </p:nvGraphicFramePr>
+        <p:xfrm>
+          <a:off x="457200" y="1005840"/>
+          <a:ext cx="5120640" cy="3108960"/>
+        </p:xfrm>
+        <a:graphic>
+          <a:graphicData uri="http://schemas.openxmlformats.org/drawingml/2006/chart">
+            <c:chart xmlns:c="http://schemas.openxmlformats.org/drawingml/2006/chart" r:id="rId3"/>
+          </a:graphicData>
+        </a:graphic>
+      </p:graphicFrame>
+      <p:sp>
+        <p:nvSpPr>
+          <p:cNvPr id="4" name="TextBox 3"/>
+          <p:cNvSpPr txBox="1"/>
+          <p:nvPr/>
+        </p:nvSpPr>
+        <p:spPr>
+          <a:xfrm>
+            <a:off x="5943600" y="1005840"/>
+            <a:ext cx="2743200" cy="548640"/>
+          </a:xfrm>
+          <a:prstGeom prst="rect">
+            <a:avLst/>
+          </a:prstGeom>
+          <a:noFill/>
+        </p:spPr>
+        <p:txBody>
+          <a:bodyPr wrap="square" lIns="0" rIns="0" tIns="0" bIns="0" anchor="t">
+            <a:spAutoFit/>
+          </a:bodyPr>
+          <a:lstStyle/>
+          <a:p>
+            <a:pPr algn="l"/>
+            <a:r>
+              <a:rPr sz="3000" b="1" i="0">
+                <a:solidFill>
+                  <a:srgbClr val="BB0027"/>
+                </a:solidFill>
+                <a:latin typeface="Open Sans"/>
+              </a:rPr>
+              <a:t>1.36×</a:t>
+            </a:r>
+          </a:p>
+        </p:txBody>
+      </p:sp>
       <p:sp>
         <p:nvSpPr>
           <p:cNvPr id="5" name="TextBox 4"/>
@@ -9948,8 +11923,8 @@
         </p:nvSpPr>
         <p:spPr>
           <a:xfrm>
-            <a:off x="457200" y="3291840"/>
-            <a:ext cx="4023360" cy="640080"/>
+            <a:off x="5943600" y="1572768"/>
+            <a:ext cx="2743200" cy="548640"/>
           </a:xfrm>
           <a:prstGeom prst="rect">
             <a:avLst/>
@@ -9964,13 +11939,13 @@
           <a:p>
             <a:pPr algn="l"/>
             <a:r>
-              <a:rPr sz="1050" b="0" i="0">
+              <a:rPr sz="1200" b="0" i="0">
                 <a:solidFill>
                   <a:srgbClr val="5A6875"/>
                 </a:solidFill>
                 <a:latin typeface="Open Sans"/>
               </a:rPr>
-              <a:t>2×6 asm 90.2% mean (C = 32–256); 2×5 81.4%. SiLU costs a fixed 160–290 cycles per call.</a:t>
+              <a:t>v10 vs OpenCV DNN (84% of peak vs 62%)</a:t>
             </a:r>
           </a:p>
         </p:txBody>
@@ -9983,8 +11958,8 @@
         </p:nvSpPr>
         <p:spPr>
           <a:xfrm>
-            <a:off x="4663440" y="3291840"/>
-            <a:ext cx="4023360" cy="640080"/>
+            <a:off x="5943600" y="2057400"/>
+            <a:ext cx="2743200" cy="548640"/>
           </a:xfrm>
           <a:prstGeom prst="rect">
             <a:avLst/>
@@ -9999,13 +11974,83 @@
           <a:p>
             <a:pPr algn="l"/>
             <a:r>
-              <a:rPr sz="1050" b="0" i="0">
-                <a:solidFill>
-                  <a:srgbClr val="5A6875"/>
+              <a:rPr sz="3000" b="1" i="0">
+                <a:solidFill>
+                  <a:srgbClr val="6B7782"/>
                 </a:solidFill>
                 <a:latin typeface="Open Sans"/>
               </a:rPr>
-              <a:t>4×3 asm: best 87.5% at C = 120, 57% at C = 256: its weights leave L2 (cache blocking fixes this).</a:t>
+              <a:t>1.24×</a:t>
+            </a:r>
+          </a:p>
+        </p:txBody>
+      </p:sp>
+      <p:sp>
+        <p:nvSpPr>
+          <p:cNvPr id="7" name="TextBox 6"/>
+          <p:cNvSpPr txBox="1"/>
+          <p:nvPr/>
+        </p:nvSpPr>
+        <p:spPr>
+          <a:xfrm>
+            <a:off x="5943600" y="2624328"/>
+            <a:ext cx="2743200" cy="548640"/>
+          </a:xfrm>
+          <a:prstGeom prst="rect">
+            <a:avLst/>
+          </a:prstGeom>
+          <a:noFill/>
+        </p:spPr>
+        <p:txBody>
+          <a:bodyPr wrap="square" lIns="0" rIns="0" tIns="0" bIns="0" anchor="t">
+            <a:spAutoFit/>
+          </a:bodyPr>
+          <a:lstStyle/>
+          <a:p>
+            <a:pPr algn="l"/>
+            <a:r>
+              <a:rPr sz="1200" b="0" i="0">
+                <a:solidFill>
+                  <a:srgbClr val="5A6875"/>
+                </a:solidFill>
+                <a:latin typeface="Open Sans"/>
+              </a:rPr>
+              <a:t>v2, the first working kernel, vs OpenCV</a:t>
+            </a:r>
+          </a:p>
+        </p:txBody>
+      </p:sp>
+      <p:sp>
+        <p:nvSpPr>
+          <p:cNvPr id="8" name="TextBox 7"/>
+          <p:cNvSpPr txBox="1"/>
+          <p:nvPr/>
+        </p:nvSpPr>
+        <p:spPr>
+          <a:xfrm>
+            <a:off x="5943600" y="3154680"/>
+            <a:ext cx="2743200" cy="1005840"/>
+          </a:xfrm>
+          <a:prstGeom prst="rect">
+            <a:avLst/>
+          </a:prstGeom>
+          <a:noFill/>
+        </p:spPr>
+        <p:txBody>
+          <a:bodyPr wrap="square" lIns="0" rIns="0" tIns="0" bIns="0" anchor="t">
+            <a:spAutoFit/>
+          </a:bodyPr>
+          <a:lstStyle/>
+          <a:p>
+            <a:pPr algn="l"/>
+            <a:r>
+              <a:rPr sz="1150" b="0" i="1">
+                <a:solidFill>
+                  <a:srgbClr val="5A6875"/>
+                </a:solidFill>
+                <a:latin typeface="Open Sans"/>
+              </a:rPr>
+              <a:t>Next: cache blocking for C ≥ 128 (where 4×3 collapses), then threads on 20 cores.</a:t>
             </a:r>
           </a:p>
         </p:txBody>

</xml_diff>

<commit_message>
Mid deck: compare 2x5 vs 2x6 (intrinsics) on the tile-choice slide
Co-Authored-By: Claude Opus 5.5 <noreply@anthropic.com>
Claude-Session: https://claude.ai/code/session_01AeVaHM9UcLNRWUmMTDhqz2
</commit_message>
<xml_diff>
--- a/docs/milestone/om/slides/om_mid_presentation_cmu.pptx
+++ b/docs/milestone/om/slides/om_mid_presentation_cmu.pptx
@@ -541,7 +541,7 @@
                 </a:solidFill>
                 <a:latin typeface="Open Sans"/>
               </a:rPr>
-              <a:t>% of peak: alone (C = 64) vs in layers</a:t>
+              <a:t>% of peak: alone (C = 64) vs all 32 layers</a:t>
             </a:r>
           </a:p>
         </c:rich>
@@ -579,10 +579,10 @@
               <c:strCache>
                 <c:ptCount val="2"/>
                 <c:pt idx="0">
-                  <c:v>1×10 (10 acc)</c:v>
+                  <c:v>2×5 (v2)</c:v>
                 </c:pt>
                 <c:pt idx="1">
-                  <c:v>2×5 (10 acc)</c:v>
+                  <c:v>2×6 (v4)</c:v>
                 </c:pt>
               </c:strCache>
             </c:strRef>
@@ -594,10 +594,10 @@
                 <c:formatCode>General</c:formatCode>
                 <c:ptCount val="2"/>
                 <c:pt idx="0">
-                  <c:v>85.8</c:v>
+                  <c:v>85.3</c:v>
                 </c:pt>
                 <c:pt idx="1">
-                  <c:v>85.3</c:v>
+                  <c:v>81.2</c:v>
                 </c:pt>
               </c:numCache>
             </c:numRef>
@@ -628,10 +628,10 @@
               <c:strCache>
                 <c:ptCount val="2"/>
                 <c:pt idx="0">
-                  <c:v>1×10 (10 acc)</c:v>
+                  <c:v>2×5 (v2)</c:v>
                 </c:pt>
                 <c:pt idx="1">
-                  <c:v>2×5 (10 acc)</c:v>
+                  <c:v>2×6 (v4)</c:v>
                 </c:pt>
               </c:strCache>
             </c:strRef>
@@ -643,10 +643,10 @@
                 <c:formatCode>General</c:formatCode>
                 <c:ptCount val="2"/>
                 <c:pt idx="0">
-                  <c:v>67.0</c:v>
+                  <c:v>76.8</c:v>
                 </c:pt>
                 <c:pt idx="1">
-                  <c:v>76.8</c:v>
+                  <c:v>75.3</c:v>
                 </c:pt>
               </c:numCache>
             </c:numRef>
@@ -2282,7 +2282,7 @@
           <a:lstStyle/>
           <a:p>
             <a:r>
-              <a:t>Two tiles with the same 10 accumulators: 1x10, one block of 8 channels times 10 pixels, and 2x5. Alone they tie: 85.8 and 85.3 percent. Inside real layers 2x5 wins by 10 points: 76.8 against 67.0. Alone, everything sits in L1, so 1x10's 11 loads per 10 FMAs still fit through the 2 load ports. In a layer the inputs and weights stream from L2, and because each 1x10 call covers only 8 output channels, the layer reads every input row twice as often as with 2x5. So loads become the limit. 2x5 needs only 7 loads per 10 FMAs, so it has room to spare. Lesson: pick the tile in the real layer, not only alone.</a:t>
+              <a:t>The natural next step after 2x5 was 2x6: 12 accumulators instead of 10, two chains of slack beyond the minimum, still under 16 registers. On paper it should be at least as fast. Measured, it loses both alone and in the layers: 81.2 against 85.3 percent alone at C = 64, and 75.3 against 76.8 in all 32 layers. The reason is in GCC's generated code: at 15 live registers it inserts 11 register-to-register copies per tap, against 2 for 2x5. Those copies take issue slots the FMAs need, so the extra accumulators buy nothing. With intrinsics the compiler, not us, assigns registers, so the tile that leaves GCC room, 2x5 with 13 registers, is the one we keep. In the layers the gap shrinks to 1.5 points because both kernels then also wait on data from L2.</a:t>
             </a:r>
           </a:p>
         </p:txBody>
@@ -7653,7 +7653,7 @@
           <a:lstStyle/>
           <a:p>
             <a:r>
-              <a:t>Tied alone, 10 points apart in the layers</a:t>
+              <a:t>12 accumulators lost to 10: GCC's register copies</a:t>
             </a:r>
           </a:p>
         </p:txBody>
@@ -7686,7 +7686,7 @@
         </p:nvGraphicFramePr>
         <p:xfrm>
           <a:off x="4754880" y="1051560"/>
-          <a:ext cx="3931920" cy="1371600"/>
+          <a:ext cx="3931920" cy="1645920"/>
         </p:xfrm>
         <a:graphic>
           <a:graphicData uri="http://schemas.openxmlformats.org/drawingml/2006/table">
@@ -7695,38 +7695,16 @@
                 <a:tableStyleId>{5C22544A-7EE6-4342-B048-85BDC9FD1C3A}</a:tableStyleId>
               </a:tblPr>
               <a:tblGrid>
-                <a:gridCol w="2103120"/>
-                <a:gridCol w="914400"/>
-                <a:gridCol w="914400"/>
+                <a:gridCol w="2286000"/>
+                <a:gridCol w="822960"/>
+                <a:gridCol w="822960"/>
               </a:tblGrid>
-              <a:tr h="342900">
+              <a:tr h="329184">
                 <a:tc>
                   <a:txBody>
                     <a:bodyPr/>
                     <a:lstStyle/>
                     <a:p/>
-                  </a:txBody>
-                  <a:tcPr>
-                    <a:solidFill>
-                      <a:srgbClr val="F1F3F5"/>
-                    </a:solidFill>
-                  </a:tcPr>
-                </a:tc>
-                <a:tc>
-                  <a:txBody>
-                    <a:bodyPr/>
-                    <a:lstStyle/>
-                    <a:p>
-                      <a:r>
-                        <a:rPr sz="1100" b="1">
-                          <a:solidFill>
-                            <a:srgbClr val="1B2630"/>
-                          </a:solidFill>
-                          <a:latin typeface="Open Sans"/>
-                        </a:rPr>
-                        <a:t>1×10</a:t>
-                      </a:r>
-                    </a:p>
                   </a:txBody>
                   <a:tcPr>
                     <a:solidFill>
@@ -7756,8 +7734,30 @@
                     </a:solidFill>
                   </a:tcPr>
                 </a:tc>
+                <a:tc>
+                  <a:txBody>
+                    <a:bodyPr/>
+                    <a:lstStyle/>
+                    <a:p>
+                      <a:r>
+                        <a:rPr sz="1100" b="1">
+                          <a:solidFill>
+                            <a:srgbClr val="1B2630"/>
+                          </a:solidFill>
+                          <a:latin typeface="Open Sans"/>
+                        </a:rPr>
+                        <a:t>2×6</a:t>
+                      </a:r>
+                    </a:p>
+                  </a:txBody>
+                  <a:tcPr>
+                    <a:solidFill>
+                      <a:srgbClr val="F1F3F5"/>
+                    </a:solidFill>
+                  </a:tcPr>
+                </a:tc>
               </a:tr>
-              <a:tr h="342900">
+              <a:tr h="329184">
                 <a:tc>
                   <a:txBody>
                     <a:bodyPr/>
@@ -7770,7 +7770,7 @@
                           </a:solidFill>
                           <a:latin typeface="Open Sans"/>
                         </a:rPr>
-                        <a:t>Loads per 10 FMAs</a:t>
+                        <a:t>Accumulators</a:t>
                       </a:r>
                     </a:p>
                   </a:txBody>
@@ -7792,7 +7792,7 @@
                           </a:solidFill>
                           <a:latin typeface="Open Sans"/>
                         </a:rPr>
-                        <a:t>11</a:t>
+                        <a:t>10</a:t>
                       </a:r>
                     </a:p>
                   </a:txBody>
@@ -7814,7 +7814,7 @@
                           </a:solidFill>
                           <a:latin typeface="Open Sans"/>
                         </a:rPr>
-                        <a:t>7</a:t>
+                        <a:t>12</a:t>
                       </a:r>
                     </a:p>
                   </a:txBody>
@@ -7825,7 +7825,7 @@
                   </a:tcPr>
                 </a:tc>
               </a:tr>
-              <a:tr h="342900">
+              <a:tr h="329184">
                 <a:tc>
                   <a:txBody>
                     <a:bodyPr/>
@@ -7838,7 +7838,7 @@
                           </a:solidFill>
                           <a:latin typeface="Open Sans"/>
                         </a:rPr>
-                        <a:t>Output channels per call</a:t>
+                        <a:t>Registers used (of 16)</a:t>
                       </a:r>
                     </a:p>
                   </a:txBody>
@@ -7860,7 +7860,7 @@
                           </a:solidFill>
                           <a:latin typeface="Open Sans"/>
                         </a:rPr>
-                        <a:t>8</a:t>
+                        <a:t>13</a:t>
                       </a:r>
                     </a:p>
                   </a:txBody>
@@ -7882,7 +7882,7 @@
                           </a:solidFill>
                           <a:latin typeface="Open Sans"/>
                         </a:rPr>
-                        <a:t>16</a:t>
+                        <a:t>15</a:t>
                       </a:r>
                     </a:p>
                   </a:txBody>
@@ -7893,7 +7893,7 @@
                   </a:tcPr>
                 </a:tc>
               </a:tr>
-              <a:tr h="342900">
+              <a:tr h="329184">
                 <a:tc>
                   <a:txBody>
                     <a:bodyPr/>
@@ -7906,7 +7906,75 @@
                           </a:solidFill>
                           <a:latin typeface="Open Sans"/>
                         </a:rPr>
-                        <a:t>Times each input row is read</a:t>
+                        <a:t>Register copies per tap (GCC)</a:t>
+                      </a:r>
+                    </a:p>
+                  </a:txBody>
+                  <a:tcPr>
+                    <a:solidFill>
+                      <a:srgbClr val="F8E5E9"/>
+                    </a:solidFill>
+                  </a:tcPr>
+                </a:tc>
+                <a:tc>
+                  <a:txBody>
+                    <a:bodyPr/>
+                    <a:lstStyle/>
+                    <a:p>
+                      <a:r>
+                        <a:rPr sz="1100" b="0">
+                          <a:solidFill>
+                            <a:srgbClr val="1B2630"/>
+                          </a:solidFill>
+                          <a:latin typeface="Open Sans"/>
+                        </a:rPr>
+                        <a:t>2</a:t>
+                      </a:r>
+                    </a:p>
+                  </a:txBody>
+                  <a:tcPr>
+                    <a:solidFill>
+                      <a:srgbClr val="F8E5E9"/>
+                    </a:solidFill>
+                  </a:tcPr>
+                </a:tc>
+                <a:tc>
+                  <a:txBody>
+                    <a:bodyPr/>
+                    <a:lstStyle/>
+                    <a:p>
+                      <a:r>
+                        <a:rPr sz="1100" b="0">
+                          <a:solidFill>
+                            <a:srgbClr val="1B2630"/>
+                          </a:solidFill>
+                          <a:latin typeface="Open Sans"/>
+                        </a:rPr>
+                        <a:t>11</a:t>
+                      </a:r>
+                    </a:p>
+                  </a:txBody>
+                  <a:tcPr>
+                    <a:solidFill>
+                      <a:srgbClr val="F8E5E9"/>
+                    </a:solidFill>
+                  </a:tcPr>
+                </a:tc>
+              </a:tr>
+              <a:tr h="329184">
+                <a:tc>
+                  <a:txBody>
+                    <a:bodyPr/>
+                    <a:lstStyle/>
+                    <a:p>
+                      <a:r>
+                        <a:rPr sz="1100" b="0">
+                          <a:solidFill>
+                            <a:srgbClr val="1B2630"/>
+                          </a:solidFill>
+                          <a:latin typeface="Open Sans"/>
+                        </a:rPr>
+                        <a:t>Spills</a:t>
                       </a:r>
                     </a:p>
                   </a:txBody>
@@ -7928,7 +7996,7 @@
                           </a:solidFill>
                           <a:latin typeface="Open Sans"/>
                         </a:rPr>
-                        <a:t>2×</a:t>
+                        <a:t>0</a:t>
                       </a:r>
                     </a:p>
                   </a:txBody>
@@ -7950,7 +8018,7 @@
                           </a:solidFill>
                           <a:latin typeface="Open Sans"/>
                         </a:rPr>
-                        <a:t>1×</a:t>
+                        <a:t>0</a:t>
                       </a:r>
                     </a:p>
                   </a:txBody>
@@ -7973,8 +8041,8 @@
         </p:nvSpPr>
         <p:spPr>
           <a:xfrm>
-            <a:off x="4754880" y="2606040"/>
-            <a:ext cx="3931920" cy="822960"/>
+            <a:off x="4754880" y="2834640"/>
+            <a:ext cx="3931920" cy="731520"/>
           </a:xfrm>
           <a:prstGeom prst="rect">
             <a:avLst/>
@@ -7995,7 +8063,7 @@
                 </a:solidFill>
                 <a:latin typeface="Open Sans"/>
               </a:rPr>
-              <a:t>Alone: </a:t>
+              <a:t>Expected: </a:t>
             </a:r>
             <a:r>
               <a:rPr sz="1150" b="0" i="0">
@@ -8004,7 +8072,7 @@
                 </a:solidFill>
                 <a:latin typeface="Open Sans"/>
               </a:rPr>
-              <a:t>all data in L1, so 1×10's extra loads still fit.</a:t>
+              <a:t>12 chains ≥ 10 chains, so 2×6 at least as fast.</a:t>
             </a:r>
           </a:p>
           <a:p>
@@ -8020,7 +8088,7 @@
                 </a:solidFill>
                 <a:latin typeface="Open Sans"/>
               </a:rPr>
-              <a:t>In a layer: </a:t>
+              <a:t>Measured: </a:t>
             </a:r>
             <a:r>
               <a:rPr sz="1150" b="0" i="0">
@@ -8029,7 +8097,7 @@
                 </a:solidFill>
                 <a:latin typeface="Open Sans"/>
               </a:rPr>
-              <a:t>data streams from L2 and 1×10 reads inputs twice as often, so loads become the limit.</a:t>
+              <a:t>GCC's extra copies take issue slots from the FMAs; 2×6 loses alone and in layers.</a:t>
             </a:r>
           </a:p>
         </p:txBody>
@@ -8042,8 +8110,8 @@
         </p:nvSpPr>
         <p:spPr>
           <a:xfrm>
-            <a:off x="4754880" y="3611880"/>
-            <a:ext cx="3931920" cy="548640"/>
+            <a:off x="4754880" y="3703320"/>
+            <a:ext cx="3931920" cy="457200"/>
           </a:xfrm>
           <a:prstGeom prst="rect">
             <a:avLst/>
@@ -8058,48 +8126,13 @@
           <a:p>
             <a:pPr algn="l"/>
             <a:r>
-              <a:rPr sz="1400" b="1" i="1">
+              <a:rPr sz="1300" b="1" i="1">
                 <a:solidFill>
                   <a:srgbClr val="BB0027"/>
                 </a:solidFill>
                 <a:latin typeface="Open Sans"/>
               </a:rPr>
-              <a:t>Pick the tile in the real layer, not only alone.</a:t>
-            </a:r>
-          </a:p>
-        </p:txBody>
-      </p:sp>
-      <p:sp>
-        <p:nvSpPr>
-          <p:cNvPr id="7" name="TextBox 6"/>
-          <p:cNvSpPr txBox="1"/>
-          <p:nvPr/>
-        </p:nvSpPr>
-        <p:spPr>
-          <a:xfrm>
-            <a:off x="4754880" y="4114800"/>
-            <a:ext cx="3931920" cy="182880"/>
-          </a:xfrm>
-          <a:prstGeom prst="rect">
-            <a:avLst/>
-          </a:prstGeom>
-          <a:noFill/>
-        </p:spPr>
-        <p:txBody>
-          <a:bodyPr wrap="square" lIns="0" rIns="0" tIns="0" bIns="0" anchor="t">
-            <a:spAutoFit/>
-          </a:bodyPr>
-          <a:lstStyle/>
-          <a:p>
-            <a:pPr algn="l"/>
-            <a:r>
-              <a:rPr sz="900" b="0" i="0">
-                <a:solidFill>
-                  <a:srgbClr val="5A6875"/>
-                </a:solidFill>
-                <a:latin typeface="Open Sans"/>
-              </a:rPr>
-              <a:t>1×10 in layers: 4-layer tile sweep (C = 16–128).</a:t>
+              <a:t>With intrinsics, pick the tile that leaves the compiler room.</a:t>
             </a:r>
           </a:p>
         </p:txBody>

</xml_diff>

<commit_message>
bench_ukr: cycles = TSC ticks x turbo/base (3.4/2.4) by default, --base, warn if TSC rate differs
Co-Authored-By: Claude Opus 5.5 <noreply@anthropic.com>
Claude-Session: https://claude.ai/code/session_01AeVaHM9UcLNRWUmMTDhqz2
</commit_message>
<xml_diff>
--- a/docs/milestone/om/slides/om_mid_presentation_cmu.pptx
+++ b/docs/milestone/om/slides/om_mid_presentation_cmu.pptx
@@ -2772,7 +2772,7 @@
           <a:lstStyle/>
           <a:p>
             <a:r>
-              <a:t>These are the assumptions behind every number in the talk. The important one: cycles are wall time times 3.4 GHz, the CPU's maximum turbo, exactly the Assignment 2 convention. The core can never run faster than that, so the percentages can only understate.</a:t>
+              <a:t>These are the assumptions behind every number in the talk. The important one: we count rdtsc ticks, which run at the fixed 2.4 GHz base clock, and scale them by 3.4 over 2.4, the ratio of max turbo to base, exactly the Assignment 2 convention. The core can never run faster than that, so the percentages can only understate.</a:t>
             </a:r>
           </a:p>
         </p:txBody>
@@ -12724,7 +12724,7 @@
                 </a:solidFill>
                 <a:latin typeface="Open Sans"/>
               </a:rPr>
-              <a:t>wall time × 3.4 GHz (max turbo), as in Assignment 2: can only understate % of peak</a:t>
+              <a:t>rdtsc ticks (fixed 2.4 GHz base) × 3.4 / 2.4 = cycles at max turbo, as in A2: can only understate</a:t>
             </a:r>
           </a:p>
         </p:txBody>

</xml_diff>